<commit_message>
Add operational intelligence and impact evidence
</commit_message>
<xml_diff>
--- a/public/Thomas-Ryan-PepperBall-Platform-Case-Study.pptx
+++ b/public/Thomas-Ryan-PepperBall-Platform-Case-Study.pptx
@@ -2,18 +2,19 @@
 <file path=ppt/presentation.xml><?xml version="1.0" encoding="utf-8"?>
 <p:presentation xmlns:p="http://schemas.openxmlformats.org/presentationml/2006/main">
   <p:sldMasterIdLst>
-    <p:sldMasterId xmlns:r="http://schemas.openxmlformats.org/officeDocument/2006/relationships" id="2147483648" r:id="R6bbe71c510564cf7"/>
+    <p:sldMasterId xmlns:r="http://schemas.openxmlformats.org/officeDocument/2006/relationships" id="2147483648" r:id="R3c01c346d7cb4acc"/>
   </p:sldMasterIdLst>
   <p:notesMasterIdLst>
-    <p:notesMasterId xmlns:r="http://schemas.openxmlformats.org/officeDocument/2006/relationships" r:id="R28479908b9954e53"/>
+    <p:notesMasterId xmlns:r="http://schemas.openxmlformats.org/officeDocument/2006/relationships" r:id="R9fb2f034ed0c4821"/>
   </p:notesMasterIdLst>
   <p:sldIdLst>
-    <p:sldId xmlns:r="http://schemas.openxmlformats.org/officeDocument/2006/relationships" id="256" r:id="Rc284425b91c6460a"/>
-    <p:sldId xmlns:r="http://schemas.openxmlformats.org/officeDocument/2006/relationships" id="257" r:id="R3fd7139484ab4f60"/>
-    <p:sldId xmlns:r="http://schemas.openxmlformats.org/officeDocument/2006/relationships" id="258" r:id="R0e17ee1301ef4c47"/>
-    <p:sldId xmlns:r="http://schemas.openxmlformats.org/officeDocument/2006/relationships" id="259" r:id="R765e16e5f3864bcd"/>
-    <p:sldId xmlns:r="http://schemas.openxmlformats.org/officeDocument/2006/relationships" id="260" r:id="R51fa092a455740f8"/>
-    <p:sldId xmlns:r="http://schemas.openxmlformats.org/officeDocument/2006/relationships" id="261" r:id="R5584c65fa8874236"/>
+    <p:sldId xmlns:r="http://schemas.openxmlformats.org/officeDocument/2006/relationships" id="256" r:id="R5b3f4387ff9e47ba"/>
+    <p:sldId xmlns:r="http://schemas.openxmlformats.org/officeDocument/2006/relationships" id="257" r:id="R8c8028a17ba54f1b"/>
+    <p:sldId xmlns:r="http://schemas.openxmlformats.org/officeDocument/2006/relationships" id="258" r:id="Ra6419a8a9e8f42a1"/>
+    <p:sldId xmlns:r="http://schemas.openxmlformats.org/officeDocument/2006/relationships" id="259" r:id="Rbc57a05a0a4648a7"/>
+    <p:sldId xmlns:r="http://schemas.openxmlformats.org/officeDocument/2006/relationships" id="260" r:id="R8a54f1e7c7834941"/>
+    <p:sldId xmlns:r="http://schemas.openxmlformats.org/officeDocument/2006/relationships" id="261" r:id="Rdb84316618a541a0"/>
+    <p:sldId xmlns:r="http://schemas.openxmlformats.org/officeDocument/2006/relationships" id="262" r:id="R8d79930cb7d74e3f"/>
   </p:sldIdLst>
   <p:sldSz cx="12192000" cy="6858000"/>
   <p:notesSz cx="6858000" cy="9144000"/>
@@ -857,6 +858,81 @@
 </p:notes>
 </file>
 
+<file path=ppt/notesSlides/notesSlide7.xml><?xml version="1.0" encoding="utf-8"?>
+<p:notes xmlns:p="http://schemas.openxmlformats.org/presentationml/2006/main">
+  <p:cSld>
+    <p:spTree>
+      <p:nvGrpSpPr>
+        <p:cNvPr id="1" name=""/>
+        <p:cNvGrpSpPr/>
+        <p:nvPr/>
+      </p:nvGrpSpPr>
+      <p:grpSpPr>
+        <a:xfrm xmlns:a="http://schemas.openxmlformats.org/drawingml/2006/main"/>
+      </p:grpSpPr>
+      <p:sp>
+        <p:nvSpPr>
+          <p:cNvPr id="2" name="Slide Image Placeholder 1"/>
+          <p:cNvSpPr>
+            <a:spLocks xmlns:a="http://schemas.openxmlformats.org/drawingml/2006/main" noGrp="1"/>
+          </p:cNvSpPr>
+          <p:nvPr>
+            <p:ph type="sldImg" idx="0"/>
+          </p:nvPr>
+        </p:nvSpPr>
+        <p:spPr/>
+      </p:sp>
+      <p:sp>
+        <p:nvSpPr>
+          <p:cNvPr id="3" name="Notes Placeholder 2"/>
+          <p:cNvSpPr>
+            <a:spLocks xmlns:a="http://schemas.openxmlformats.org/drawingml/2006/main" noGrp="1"/>
+          </p:cNvSpPr>
+          <p:nvPr>
+            <p:ph type="body" idx="1"/>
+          </p:nvPr>
+        </p:nvSpPr>
+        <p:spPr/>
+        <p:txBody>
+          <a:bodyPr xmlns:a="http://schemas.openxmlformats.org/drawingml/2006/main"/>
+          <a:lstStyle xmlns:a="http://schemas.openxmlformats.org/drawingml/2006/main"/>
+          <a:p xmlns:a="http://schemas.openxmlformats.org/drawingml/2006/main">
+            <a:r>
+              <a:t>[Sources]</a:t>
+            </a:r>
+          </a:p>
+          <a:p xmlns:a="http://schemas.openxmlformats.org/drawingml/2006/main">
+            <a:r>
+              <a:t>- User-provided project evidence and retained impact methodology.</a:t>
+            </a:r>
+          </a:p>
+        </p:txBody>
+      </p:sp>
+      <p:sp>
+        <p:nvSpPr>
+          <p:cNvPr id="4" name="Slide Number Placeholder 3"/>
+          <p:cNvSpPr>
+            <a:spLocks xmlns:a="http://schemas.openxmlformats.org/drawingml/2006/main" noGrp="1"/>
+          </p:cNvSpPr>
+          <p:nvPr>
+            <p:ph type="sldNum" idx="5"/>
+          </p:nvPr>
+        </p:nvSpPr>
+        <p:spPr/>
+        <p:txBody>
+          <a:bodyPr xmlns:a="http://schemas.openxmlformats.org/drawingml/2006/main"/>
+          <a:lstStyle xmlns:a="http://schemas.openxmlformats.org/drawingml/2006/main"/>
+          <a:p xmlns:a="http://schemas.openxmlformats.org/drawingml/2006/main"/>
+        </p:txBody>
+      </p:sp>
+    </p:spTree>
+  </p:cSld>
+  <p:clrMapOvr>
+    <a:masterClrMapping xmlns:a="http://schemas.openxmlformats.org/drawingml/2006/main"/>
+  </p:clrMapOvr>
+</p:notes>
+</file>
+
 <file path=ppt/slideLayouts/slideLayout1.xml><?xml version="1.0" encoding="utf-8"?>
 <p:sldLayout xmlns:p="http://schemas.openxmlformats.org/presentationml/2006/main" type="title">
   <p:cSld name="Title Slide">
@@ -895,7 +971,7 @@
   </p:cSld>
   <p:clrMap bg1="lt1" tx1="dk1" bg2="lt2" tx2="dk2" accent1="accent1" accent2="accent2" accent3="accent3" accent4="accent4" accent5="accent5" accent6="accent6" hlink="hlink" folHlink="folHlink"/>
   <p:sldLayoutIdLst>
-    <p:sldLayoutId xmlns:r="http://schemas.openxmlformats.org/officeDocument/2006/relationships" id="2147483649" r:id="R4c876d980ad64382"/>
+    <p:sldLayoutId xmlns:r="http://schemas.openxmlformats.org/officeDocument/2006/relationships" id="2147483649" r:id="Re46150db4e71499b"/>
   </p:sldLayoutIdLst>
   <p:txStyles>
     <p:titleStyle>
@@ -1474,6 +1550,7 @@
           <a:lstStyle xmlns:a="http://schemas.openxmlformats.org/drawingml/2006/main"/>
           <a:p xmlns:a="http://schemas.openxmlformats.org/drawingml/2006/main">
             <a:pPr algn="l">
+              <a:buNone/>
               <a:defRPr sz="1050" b="1">
                 <a:solidFill>
                   <a:srgbClr val="D52B1E"/>
@@ -1524,6 +1601,7 @@
           <a:lstStyle xmlns:a="http://schemas.openxmlformats.org/drawingml/2006/main"/>
           <a:p xmlns:a="http://schemas.openxmlformats.org/drawingml/2006/main">
             <a:pPr algn="l">
+              <a:buNone/>
               <a:defRPr sz="3150" b="1">
                 <a:solidFill>
                   <a:srgbClr val="171717"/>
@@ -1574,6 +1652,7 @@
           <a:lstStyle xmlns:a="http://schemas.openxmlformats.org/drawingml/2006/main"/>
           <a:p xmlns:a="http://schemas.openxmlformats.org/drawingml/2006/main">
             <a:pPr algn="l">
+              <a:buNone/>
               <a:defRPr sz="825" b="1">
                 <a:solidFill>
                   <a:srgbClr val="626262"/>
@@ -1624,6 +1703,7 @@
           <a:lstStyle xmlns:a="http://schemas.openxmlformats.org/drawingml/2006/main"/>
           <a:p xmlns:a="http://schemas.openxmlformats.org/drawingml/2006/main">
             <a:pPr algn="l">
+              <a:buNone/>
               <a:defRPr sz="1800" b="0">
                 <a:solidFill>
                   <a:srgbClr val="626262"/>
@@ -1709,6 +1789,7 @@
           <a:lstStyle xmlns:a="http://schemas.openxmlformats.org/drawingml/2006/main"/>
           <a:p xmlns:a="http://schemas.openxmlformats.org/drawingml/2006/main">
             <a:pPr algn="l">
+              <a:buNone/>
               <a:defRPr sz="1050" b="1">
                 <a:solidFill>
                   <a:srgbClr val="FF6A60"/>
@@ -1759,6 +1840,7 @@
           <a:lstStyle xmlns:a="http://schemas.openxmlformats.org/drawingml/2006/main"/>
           <a:p xmlns:a="http://schemas.openxmlformats.org/drawingml/2006/main">
             <a:pPr algn="l">
+              <a:buNone/>
               <a:defRPr sz="1875" b="1">
                 <a:solidFill>
                   <a:srgbClr val="FFFFFF"/>
@@ -1776,6 +1858,7 @@
           </a:p>
           <a:p xmlns:a="http://schemas.openxmlformats.org/drawingml/2006/main">
             <a:pPr algn="l">
+              <a:buNone/>
               <a:defRPr sz="1875" b="1">
                 <a:solidFill>
                   <a:srgbClr val="FFFFFF"/>
@@ -1793,6 +1876,7 @@
           </a:p>
           <a:p xmlns:a="http://schemas.openxmlformats.org/drawingml/2006/main">
             <a:pPr algn="l">
+              <a:buNone/>
               <a:defRPr sz="1875" b="1">
                 <a:solidFill>
                   <a:srgbClr val="FFFFFF"/>
@@ -1872,6 +1956,7 @@
           <a:lstStyle xmlns:a="http://schemas.openxmlformats.org/drawingml/2006/main"/>
           <a:p xmlns:a="http://schemas.openxmlformats.org/drawingml/2006/main">
             <a:pPr algn="l">
+              <a:buNone/>
               <a:defRPr sz="1050" b="1">
                 <a:solidFill>
                   <a:srgbClr val="D52B1E"/>
@@ -1922,6 +2007,7 @@
           <a:lstStyle xmlns:a="http://schemas.openxmlformats.org/drawingml/2006/main"/>
           <a:p xmlns:a="http://schemas.openxmlformats.org/drawingml/2006/main">
             <a:pPr algn="l">
+              <a:buNone/>
               <a:defRPr sz="3150" b="1">
                 <a:solidFill>
                   <a:srgbClr val="171717"/>
@@ -1972,6 +2058,7 @@
           <a:lstStyle xmlns:a="http://schemas.openxmlformats.org/drawingml/2006/main"/>
           <a:p xmlns:a="http://schemas.openxmlformats.org/drawingml/2006/main">
             <a:pPr algn="l">
+              <a:buNone/>
               <a:defRPr sz="825" b="1">
                 <a:solidFill>
                   <a:srgbClr val="626262"/>
@@ -2022,6 +2109,7 @@
           <a:lstStyle xmlns:a="http://schemas.openxmlformats.org/drawingml/2006/main"/>
           <a:p xmlns:a="http://schemas.openxmlformats.org/drawingml/2006/main">
             <a:pPr algn="l">
+              <a:buNone/>
               <a:defRPr sz="975" b="1">
                 <a:solidFill>
                   <a:srgbClr val="D52B1E"/>
@@ -2072,6 +2160,7 @@
           <a:lstStyle xmlns:a="http://schemas.openxmlformats.org/drawingml/2006/main"/>
           <a:p xmlns:a="http://schemas.openxmlformats.org/drawingml/2006/main">
             <a:pPr algn="l">
+              <a:buNone/>
               <a:defRPr sz="1875" b="1">
                 <a:solidFill>
                   <a:srgbClr val="171717"/>
@@ -2122,6 +2211,7 @@
           <a:lstStyle xmlns:a="http://schemas.openxmlformats.org/drawingml/2006/main"/>
           <a:p xmlns:a="http://schemas.openxmlformats.org/drawingml/2006/main">
             <a:pPr algn="l">
+              <a:buNone/>
               <a:defRPr sz="1650" b="0">
                 <a:solidFill>
                   <a:srgbClr val="626262"/>
@@ -2207,6 +2297,7 @@
           <a:lstStyle xmlns:a="http://schemas.openxmlformats.org/drawingml/2006/main"/>
           <a:p xmlns:a="http://schemas.openxmlformats.org/drawingml/2006/main">
             <a:pPr algn="l">
+              <a:buNone/>
               <a:defRPr sz="975" b="1">
                 <a:solidFill>
                   <a:srgbClr val="D52B1E"/>
@@ -2257,6 +2348,7 @@
           <a:lstStyle xmlns:a="http://schemas.openxmlformats.org/drawingml/2006/main"/>
           <a:p xmlns:a="http://schemas.openxmlformats.org/drawingml/2006/main">
             <a:pPr algn="l">
+              <a:buNone/>
               <a:defRPr sz="1875" b="1">
                 <a:solidFill>
                   <a:srgbClr val="171717"/>
@@ -2307,6 +2399,7 @@
           <a:lstStyle xmlns:a="http://schemas.openxmlformats.org/drawingml/2006/main"/>
           <a:p xmlns:a="http://schemas.openxmlformats.org/drawingml/2006/main">
             <a:pPr algn="l">
+              <a:buNone/>
               <a:defRPr sz="1650" b="0">
                 <a:solidFill>
                   <a:srgbClr val="626262"/>
@@ -2392,6 +2485,7 @@
           <a:lstStyle xmlns:a="http://schemas.openxmlformats.org/drawingml/2006/main"/>
           <a:p xmlns:a="http://schemas.openxmlformats.org/drawingml/2006/main">
             <a:pPr algn="l">
+              <a:buNone/>
               <a:defRPr sz="975" b="1">
                 <a:solidFill>
                   <a:srgbClr val="D52B1E"/>
@@ -2442,6 +2536,7 @@
           <a:lstStyle xmlns:a="http://schemas.openxmlformats.org/drawingml/2006/main"/>
           <a:p xmlns:a="http://schemas.openxmlformats.org/drawingml/2006/main">
             <a:pPr algn="l">
+              <a:buNone/>
               <a:defRPr sz="1875" b="1">
                 <a:solidFill>
                   <a:srgbClr val="171717"/>
@@ -2492,6 +2587,7 @@
           <a:lstStyle xmlns:a="http://schemas.openxmlformats.org/drawingml/2006/main"/>
           <a:p xmlns:a="http://schemas.openxmlformats.org/drawingml/2006/main">
             <a:pPr algn="l">
+              <a:buNone/>
               <a:defRPr sz="1650" b="0">
                 <a:solidFill>
                   <a:srgbClr val="626262"/>
@@ -2571,6 +2667,7 @@
           <a:lstStyle xmlns:a="http://schemas.openxmlformats.org/drawingml/2006/main"/>
           <a:p xmlns:a="http://schemas.openxmlformats.org/drawingml/2006/main">
             <a:pPr algn="l">
+              <a:buNone/>
               <a:defRPr sz="1050" b="1">
                 <a:solidFill>
                   <a:srgbClr val="FF6A60"/>
@@ -2621,6 +2718,7 @@
           <a:lstStyle xmlns:a="http://schemas.openxmlformats.org/drawingml/2006/main"/>
           <a:p xmlns:a="http://schemas.openxmlformats.org/drawingml/2006/main">
             <a:pPr algn="l">
+              <a:buNone/>
               <a:defRPr sz="3150" b="1">
                 <a:solidFill>
                   <a:srgbClr val="FFFFFF"/>
@@ -2671,6 +2769,7 @@
           <a:lstStyle xmlns:a="http://schemas.openxmlformats.org/drawingml/2006/main"/>
           <a:p xmlns:a="http://schemas.openxmlformats.org/drawingml/2006/main">
             <a:pPr algn="l">
+              <a:buNone/>
               <a:defRPr sz="825" b="1">
                 <a:solidFill>
                   <a:srgbClr val="AAAAAA"/>
@@ -2756,6 +2855,7 @@
           <a:lstStyle xmlns:a="http://schemas.openxmlformats.org/drawingml/2006/main"/>
           <a:p xmlns:a="http://schemas.openxmlformats.org/drawingml/2006/main">
             <a:pPr algn="l">
+              <a:buNone/>
               <a:defRPr sz="975" b="1">
                 <a:solidFill>
                   <a:srgbClr val="FF6A60"/>
@@ -2806,6 +2906,7 @@
           <a:lstStyle xmlns:a="http://schemas.openxmlformats.org/drawingml/2006/main"/>
           <a:p xmlns:a="http://schemas.openxmlformats.org/drawingml/2006/main">
             <a:pPr algn="l">
+              <a:buNone/>
               <a:defRPr sz="1650" b="1">
                 <a:solidFill>
                   <a:srgbClr val="FFFFFF"/>
@@ -2856,6 +2957,7 @@
           <a:lstStyle xmlns:a="http://schemas.openxmlformats.org/drawingml/2006/main"/>
           <a:p xmlns:a="http://schemas.openxmlformats.org/drawingml/2006/main">
             <a:pPr algn="l">
+              <a:buNone/>
               <a:defRPr sz="1200" b="0">
                 <a:solidFill>
                   <a:srgbClr val="BBBBBB"/>
@@ -2941,6 +3043,7 @@
           <a:lstStyle xmlns:a="http://schemas.openxmlformats.org/drawingml/2006/main"/>
           <a:p xmlns:a="http://schemas.openxmlformats.org/drawingml/2006/main">
             <a:pPr algn="l">
+              <a:buNone/>
               <a:defRPr sz="975" b="1">
                 <a:solidFill>
                   <a:srgbClr val="FF6A60"/>
@@ -2991,6 +3094,7 @@
           <a:lstStyle xmlns:a="http://schemas.openxmlformats.org/drawingml/2006/main"/>
           <a:p xmlns:a="http://schemas.openxmlformats.org/drawingml/2006/main">
             <a:pPr algn="l">
+              <a:buNone/>
               <a:defRPr sz="1650" b="1">
                 <a:solidFill>
                   <a:srgbClr val="FFFFFF"/>
@@ -3041,6 +3145,7 @@
           <a:lstStyle xmlns:a="http://schemas.openxmlformats.org/drawingml/2006/main"/>
           <a:p xmlns:a="http://schemas.openxmlformats.org/drawingml/2006/main">
             <a:pPr algn="l">
+              <a:buNone/>
               <a:defRPr sz="1200" b="0">
                 <a:solidFill>
                   <a:srgbClr val="BBBBBB"/>
@@ -3126,6 +3231,7 @@
           <a:lstStyle xmlns:a="http://schemas.openxmlformats.org/drawingml/2006/main"/>
           <a:p xmlns:a="http://schemas.openxmlformats.org/drawingml/2006/main">
             <a:pPr algn="l">
+              <a:buNone/>
               <a:defRPr sz="975" b="1">
                 <a:solidFill>
                   <a:srgbClr val="FF6A60"/>
@@ -3176,6 +3282,7 @@
           <a:lstStyle xmlns:a="http://schemas.openxmlformats.org/drawingml/2006/main"/>
           <a:p xmlns:a="http://schemas.openxmlformats.org/drawingml/2006/main">
             <a:pPr algn="l">
+              <a:buNone/>
               <a:defRPr sz="1650" b="1">
                 <a:solidFill>
                   <a:srgbClr val="FFFFFF"/>
@@ -3226,6 +3333,7 @@
           <a:lstStyle xmlns:a="http://schemas.openxmlformats.org/drawingml/2006/main"/>
           <a:p xmlns:a="http://schemas.openxmlformats.org/drawingml/2006/main">
             <a:pPr algn="l">
+              <a:buNone/>
               <a:defRPr sz="1200" b="0">
                 <a:solidFill>
                   <a:srgbClr val="BBBBBB"/>
@@ -3311,6 +3419,7 @@
           <a:lstStyle xmlns:a="http://schemas.openxmlformats.org/drawingml/2006/main"/>
           <a:p xmlns:a="http://schemas.openxmlformats.org/drawingml/2006/main">
             <a:pPr algn="l">
+              <a:buNone/>
               <a:defRPr sz="975" b="1">
                 <a:solidFill>
                   <a:srgbClr val="FFFFFF"/>
@@ -3361,6 +3470,7 @@
           <a:lstStyle xmlns:a="http://schemas.openxmlformats.org/drawingml/2006/main"/>
           <a:p xmlns:a="http://schemas.openxmlformats.org/drawingml/2006/main">
             <a:pPr algn="l">
+              <a:buNone/>
               <a:defRPr sz="1650" b="1">
                 <a:solidFill>
                   <a:srgbClr val="FFFFFF"/>
@@ -3411,6 +3521,7 @@
           <a:lstStyle xmlns:a="http://schemas.openxmlformats.org/drawingml/2006/main"/>
           <a:p xmlns:a="http://schemas.openxmlformats.org/drawingml/2006/main">
             <a:pPr algn="l">
+              <a:buNone/>
               <a:defRPr sz="1200" b="0">
                 <a:solidFill>
                   <a:srgbClr val="FFFFFF"/>
@@ -3490,6 +3601,7 @@
           <a:lstStyle xmlns:a="http://schemas.openxmlformats.org/drawingml/2006/main"/>
           <a:p xmlns:a="http://schemas.openxmlformats.org/drawingml/2006/main">
             <a:pPr algn="l">
+              <a:buNone/>
               <a:defRPr sz="1050" b="1">
                 <a:solidFill>
                   <a:srgbClr val="D52B1E"/>
@@ -3540,6 +3652,7 @@
           <a:lstStyle xmlns:a="http://schemas.openxmlformats.org/drawingml/2006/main"/>
           <a:p xmlns:a="http://schemas.openxmlformats.org/drawingml/2006/main">
             <a:pPr algn="l">
+              <a:buNone/>
               <a:defRPr sz="3150" b="1">
                 <a:solidFill>
                   <a:srgbClr val="171717"/>
@@ -3590,6 +3703,7 @@
           <a:lstStyle xmlns:a="http://schemas.openxmlformats.org/drawingml/2006/main"/>
           <a:p xmlns:a="http://schemas.openxmlformats.org/drawingml/2006/main">
             <a:pPr algn="l">
+              <a:buNone/>
               <a:defRPr sz="825" b="1">
                 <a:solidFill>
                   <a:srgbClr val="626262"/>
@@ -3640,6 +3754,7 @@
           <a:lstStyle xmlns:a="http://schemas.openxmlformats.org/drawingml/2006/main"/>
           <a:p xmlns:a="http://schemas.openxmlformats.org/drawingml/2006/main">
             <a:pPr algn="l">
+              <a:buNone/>
               <a:defRPr sz="1875" b="0">
                 <a:solidFill>
                   <a:srgbClr val="626262"/>
@@ -3725,6 +3840,7 @@
           <a:lstStyle xmlns:a="http://schemas.openxmlformats.org/drawingml/2006/main"/>
           <a:p xmlns:a="http://schemas.openxmlformats.org/drawingml/2006/main">
             <a:pPr algn="l">
+              <a:buNone/>
               <a:defRPr sz="975" b="1">
                 <a:solidFill>
                   <a:srgbClr val="D52B1E"/>
@@ -3775,6 +3891,7 @@
           <a:lstStyle xmlns:a="http://schemas.openxmlformats.org/drawingml/2006/main"/>
           <a:p xmlns:a="http://schemas.openxmlformats.org/drawingml/2006/main">
             <a:pPr algn="l">
+              <a:buNone/>
               <a:defRPr sz="3225" b="1">
                 <a:solidFill>
                   <a:srgbClr val="D52B1E"/>
@@ -3825,6 +3942,7 @@
           <a:lstStyle xmlns:a="http://schemas.openxmlformats.org/drawingml/2006/main"/>
           <a:p xmlns:a="http://schemas.openxmlformats.org/drawingml/2006/main">
             <a:pPr algn="l">
+              <a:buNone/>
               <a:defRPr sz="1275" b="0">
                 <a:solidFill>
                   <a:srgbClr val="626262"/>
@@ -3904,6 +4022,7 @@
           <a:lstStyle xmlns:a="http://schemas.openxmlformats.org/drawingml/2006/main"/>
           <a:p xmlns:a="http://schemas.openxmlformats.org/drawingml/2006/main">
             <a:pPr algn="l">
+              <a:buNone/>
               <a:defRPr sz="1050" b="1">
                 <a:solidFill>
                   <a:srgbClr val="FF6A60"/>
@@ -3954,6 +4073,7 @@
           <a:lstStyle xmlns:a="http://schemas.openxmlformats.org/drawingml/2006/main"/>
           <a:p xmlns:a="http://schemas.openxmlformats.org/drawingml/2006/main">
             <a:pPr algn="l">
+              <a:buNone/>
               <a:defRPr sz="3150" b="1">
                 <a:solidFill>
                   <a:srgbClr val="FFFFFF"/>
@@ -4004,6 +4124,7 @@
           <a:lstStyle xmlns:a="http://schemas.openxmlformats.org/drawingml/2006/main"/>
           <a:p xmlns:a="http://schemas.openxmlformats.org/drawingml/2006/main">
             <a:pPr algn="l">
+              <a:buNone/>
               <a:defRPr sz="825" b="1">
                 <a:solidFill>
                   <a:srgbClr val="AAAAAA"/>
@@ -4089,6 +4210,7 @@
           <a:lstStyle xmlns:a="http://schemas.openxmlformats.org/drawingml/2006/main"/>
           <a:p xmlns:a="http://schemas.openxmlformats.org/drawingml/2006/main">
             <a:pPr algn="l">
+              <a:buNone/>
               <a:defRPr sz="900" b="1">
                 <a:solidFill>
                   <a:srgbClr val="FF6A60"/>
@@ -4139,6 +4261,7 @@
           <a:lstStyle xmlns:a="http://schemas.openxmlformats.org/drawingml/2006/main"/>
           <a:p xmlns:a="http://schemas.openxmlformats.org/drawingml/2006/main">
             <a:pPr algn="l">
+              <a:buNone/>
               <a:defRPr sz="1425" b="1">
                 <a:solidFill>
                   <a:srgbClr val="FFFFFF"/>
@@ -4224,6 +4347,7 @@
           <a:lstStyle xmlns:a="http://schemas.openxmlformats.org/drawingml/2006/main"/>
           <a:p xmlns:a="http://schemas.openxmlformats.org/drawingml/2006/main">
             <a:pPr algn="l">
+              <a:buNone/>
               <a:defRPr sz="900" b="1">
                 <a:solidFill>
                   <a:srgbClr val="FF6A60"/>
@@ -4274,6 +4398,7 @@
           <a:lstStyle xmlns:a="http://schemas.openxmlformats.org/drawingml/2006/main"/>
           <a:p xmlns:a="http://schemas.openxmlformats.org/drawingml/2006/main">
             <a:pPr algn="l">
+              <a:buNone/>
               <a:defRPr sz="1425" b="1">
                 <a:solidFill>
                   <a:srgbClr val="FFFFFF"/>
@@ -4359,6 +4484,7 @@
           <a:lstStyle xmlns:a="http://schemas.openxmlformats.org/drawingml/2006/main"/>
           <a:p xmlns:a="http://schemas.openxmlformats.org/drawingml/2006/main">
             <a:pPr algn="l">
+              <a:buNone/>
               <a:defRPr sz="900" b="1">
                 <a:solidFill>
                   <a:srgbClr val="FF6A60"/>
@@ -4409,6 +4535,7 @@
           <a:lstStyle xmlns:a="http://schemas.openxmlformats.org/drawingml/2006/main"/>
           <a:p xmlns:a="http://schemas.openxmlformats.org/drawingml/2006/main">
             <a:pPr algn="l">
+              <a:buNone/>
               <a:defRPr sz="1425" b="1">
                 <a:solidFill>
                   <a:srgbClr val="FFFFFF"/>
@@ -4494,6 +4621,7 @@
           <a:lstStyle xmlns:a="http://schemas.openxmlformats.org/drawingml/2006/main"/>
           <a:p xmlns:a="http://schemas.openxmlformats.org/drawingml/2006/main">
             <a:pPr algn="l">
+              <a:buNone/>
               <a:defRPr sz="900" b="1">
                 <a:solidFill>
                   <a:srgbClr val="FF6A60"/>
@@ -4544,6 +4672,7 @@
           <a:lstStyle xmlns:a="http://schemas.openxmlformats.org/drawingml/2006/main"/>
           <a:p xmlns:a="http://schemas.openxmlformats.org/drawingml/2006/main">
             <a:pPr algn="l">
+              <a:buNone/>
               <a:defRPr sz="1425" b="1">
                 <a:solidFill>
                   <a:srgbClr val="FFFFFF"/>
@@ -4629,6 +4758,7 @@
           <a:lstStyle xmlns:a="http://schemas.openxmlformats.org/drawingml/2006/main"/>
           <a:p xmlns:a="http://schemas.openxmlformats.org/drawingml/2006/main">
             <a:pPr algn="l">
+              <a:buNone/>
               <a:defRPr sz="900" b="1">
                 <a:solidFill>
                   <a:srgbClr val="FFFFFF"/>
@@ -4679,6 +4809,7 @@
           <a:lstStyle xmlns:a="http://schemas.openxmlformats.org/drawingml/2006/main"/>
           <a:p xmlns:a="http://schemas.openxmlformats.org/drawingml/2006/main">
             <a:pPr algn="l">
+              <a:buNone/>
               <a:defRPr sz="1425" b="1">
                 <a:solidFill>
                   <a:srgbClr val="FFFFFF"/>
@@ -4758,6 +4889,7 @@
           <a:lstStyle xmlns:a="http://schemas.openxmlformats.org/drawingml/2006/main"/>
           <a:p xmlns:a="http://schemas.openxmlformats.org/drawingml/2006/main">
             <a:pPr algn="l">
+              <a:buNone/>
               <a:defRPr sz="1050" b="1">
                 <a:solidFill>
                   <a:srgbClr val="D52B1E"/>
@@ -4808,6 +4940,7 @@
           <a:lstStyle xmlns:a="http://schemas.openxmlformats.org/drawingml/2006/main"/>
           <a:p xmlns:a="http://schemas.openxmlformats.org/drawingml/2006/main">
             <a:pPr algn="l">
+              <a:buNone/>
               <a:defRPr sz="3150" b="1">
                 <a:solidFill>
                   <a:srgbClr val="171717"/>
@@ -4858,6 +4991,7 @@
           <a:lstStyle xmlns:a="http://schemas.openxmlformats.org/drawingml/2006/main"/>
           <a:p xmlns:a="http://schemas.openxmlformats.org/drawingml/2006/main">
             <a:pPr algn="l">
+              <a:buNone/>
               <a:defRPr sz="825" b="1">
                 <a:solidFill>
                   <a:srgbClr val="626262"/>
@@ -4943,6 +5077,7 @@
           <a:lstStyle xmlns:a="http://schemas.openxmlformats.org/drawingml/2006/main"/>
           <a:p xmlns:a="http://schemas.openxmlformats.org/drawingml/2006/main">
             <a:pPr algn="l">
+              <a:buNone/>
               <a:defRPr sz="975" b="1">
                 <a:solidFill>
                   <a:srgbClr val="D52B1E"/>
@@ -4993,6 +5128,7 @@
           <a:lstStyle xmlns:a="http://schemas.openxmlformats.org/drawingml/2006/main"/>
           <a:p xmlns:a="http://schemas.openxmlformats.org/drawingml/2006/main">
             <a:pPr algn="l">
+              <a:buNone/>
               <a:defRPr sz="1650" b="1">
                 <a:solidFill>
                   <a:srgbClr val="171717"/>
@@ -5078,6 +5214,7 @@
           <a:lstStyle xmlns:a="http://schemas.openxmlformats.org/drawingml/2006/main"/>
           <a:p xmlns:a="http://schemas.openxmlformats.org/drawingml/2006/main">
             <a:pPr algn="l">
+              <a:buNone/>
               <a:defRPr sz="975" b="1">
                 <a:solidFill>
                   <a:srgbClr val="D52B1E"/>
@@ -5128,6 +5265,7 @@
           <a:lstStyle xmlns:a="http://schemas.openxmlformats.org/drawingml/2006/main"/>
           <a:p xmlns:a="http://schemas.openxmlformats.org/drawingml/2006/main">
             <a:pPr algn="l">
+              <a:buNone/>
               <a:defRPr sz="1650" b="1">
                 <a:solidFill>
                   <a:srgbClr val="171717"/>
@@ -5213,6 +5351,7 @@
           <a:lstStyle xmlns:a="http://schemas.openxmlformats.org/drawingml/2006/main"/>
           <a:p xmlns:a="http://schemas.openxmlformats.org/drawingml/2006/main">
             <a:pPr algn="l">
+              <a:buNone/>
               <a:defRPr sz="975" b="1">
                 <a:solidFill>
                   <a:srgbClr val="D52B1E"/>
@@ -5263,6 +5402,7 @@
           <a:lstStyle xmlns:a="http://schemas.openxmlformats.org/drawingml/2006/main"/>
           <a:p xmlns:a="http://schemas.openxmlformats.org/drawingml/2006/main">
             <a:pPr algn="l">
+              <a:buNone/>
               <a:defRPr sz="1650" b="1">
                 <a:solidFill>
                   <a:srgbClr val="171717"/>
@@ -5348,6 +5488,7 @@
           <a:lstStyle xmlns:a="http://schemas.openxmlformats.org/drawingml/2006/main"/>
           <a:p xmlns:a="http://schemas.openxmlformats.org/drawingml/2006/main">
             <a:pPr algn="l">
+              <a:buNone/>
               <a:defRPr sz="975" b="1">
                 <a:solidFill>
                   <a:srgbClr val="D52B1E"/>
@@ -5398,6 +5539,7 @@
           <a:lstStyle xmlns:a="http://schemas.openxmlformats.org/drawingml/2006/main"/>
           <a:p xmlns:a="http://schemas.openxmlformats.org/drawingml/2006/main">
             <a:pPr algn="l">
+              <a:buNone/>
               <a:defRPr sz="1650" b="1">
                 <a:solidFill>
                   <a:srgbClr val="171717"/>
@@ -5448,6 +5590,7 @@
           <a:lstStyle xmlns:a="http://schemas.openxmlformats.org/drawingml/2006/main"/>
           <a:p xmlns:a="http://schemas.openxmlformats.org/drawingml/2006/main">
             <a:pPr algn="l">
+              <a:buNone/>
               <a:defRPr sz="1350" b="0">
                 <a:solidFill>
                   <a:srgbClr val="626262"/>
@@ -5469,6 +5612,975 @@
     <p:extLst>
       <p:ext uri="{BB962C8B-B14F-4D97-AF65-F5344CB8AC3E}">
         <p14:creationId xmlns:p14="http://schemas.microsoft.com/office/powerpoint/2010/main" val="620830455"/>
+      </p:ext>
+    </p:extLst>
+  </p:cSld>
+</p:sld>
+</file>
+
+<file path=ppt/slides/slide7.xml><?xml version="1.0" encoding="utf-8"?>
+<p:sld xmlns:p="http://schemas.openxmlformats.org/presentationml/2006/main">
+  <p:cSld>
+    <p:bg>
+      <p:bgPr>
+        <a:solidFill xmlns:a="http://schemas.openxmlformats.org/drawingml/2006/main">
+          <a:srgbClr val="F4F4F2"/>
+        </a:solidFill>
+      </p:bgPr>
+    </p:bg>
+    <p:spTree>
+      <p:nvGrpSpPr>
+        <p:cNvPr id="1" name=""/>
+        <p:cNvGrpSpPr/>
+        <p:nvPr/>
+      </p:nvGrpSpPr>
+      <p:grpSpPr>
+        <a:xfrm xmlns:a="http://schemas.openxmlformats.org/drawingml/2006/main"/>
+      </p:grpSpPr>
+      <p:sp>
+        <p:nvSpPr>
+          <p:cNvPr id="21" name="">
+            <a:extLst xmlns:a="http://schemas.openxmlformats.org/drawingml/2006/main">
+              <a:ext uri="{FF2B5EF4-FFF2-40B4-BE49-F238E27FC236}">
+                <a16:creationId xmlns:a16="http://schemas.microsoft.com/office/drawing/2014/main" id="{769B9903-2204-4827-8771-B5414D825D26}"/>
+              </a:ext>
+            </a:extLst>
+          </p:cNvPr>
+          <p:cNvSpPr>
+            <a:spLocks xmlns:a="http://schemas.openxmlformats.org/drawingml/2006/main" noGrp="1"/>
+          </p:cNvSpPr>
+          <p:nvPr/>
+        </p:nvSpPr>
+        <p:spPr>
+          <a:xfrm xmlns:a="http://schemas.openxmlformats.org/drawingml/2006/main">
+            <a:off x="533400" y="323850"/>
+            <a:ext cx="6667500" cy="247650"/>
+          </a:xfrm>
+          <a:prstGeom xmlns:a="http://schemas.openxmlformats.org/drawingml/2006/main" prst="rect">
+            <a:avLst/>
+          </a:prstGeom>
+          <a:noFill xmlns:a="http://schemas.openxmlformats.org/drawingml/2006/main"/>
+          <a:ln xmlns:a="http://schemas.openxmlformats.org/drawingml/2006/main" w="0">
+            <a:noFill/>
+            <a:prstDash val="solid"/>
+          </a:ln>
+        </p:spPr>
+        <p:txBody>
+          <a:bodyPr xmlns:a="http://schemas.openxmlformats.org/drawingml/2006/main"/>
+          <a:lstStyle xmlns:a="http://schemas.openxmlformats.org/drawingml/2006/main"/>
+          <a:p xmlns:a="http://schemas.openxmlformats.org/drawingml/2006/main">
+            <a:pPr>
+              <a:defRPr sz="1050" b="1">
+                <a:solidFill>
+                  <a:srgbClr val="D52B1E"/>
+                </a:solidFill>
+              </a:defRPr>
+            </a:pPr>
+            <a:r>
+              <a:rPr sz="1050" b="1">
+                <a:solidFill>
+                  <a:srgbClr val="D52B1E"/>
+                </a:solidFill>
+              </a:rPr>
+              <a:t>TECHNICAL APPENDIX · OPERATIONAL INTELLIGENCE</a:t>
+            </a:r>
+          </a:p>
+        </p:txBody>
+      </p:sp>
+      <p:sp>
+        <p:nvSpPr>
+          <p:cNvPr id="2" name="">
+            <a:extLst xmlns:a="http://schemas.openxmlformats.org/drawingml/2006/main">
+              <a:ext uri="{FF2B5EF4-FFF2-40B4-BE49-F238E27FC236}">
+                <a16:creationId xmlns:a16="http://schemas.microsoft.com/office/drawing/2014/main" id="{49F59429-2B01-4D8E-82DE-D8C59909767B}"/>
+              </a:ext>
+            </a:extLst>
+          </p:cNvPr>
+          <p:cNvSpPr>
+            <a:spLocks xmlns:a="http://schemas.openxmlformats.org/drawingml/2006/main" noGrp="1"/>
+          </p:cNvSpPr>
+          <p:nvPr/>
+        </p:nvSpPr>
+        <p:spPr>
+          <a:xfrm xmlns:a="http://schemas.openxmlformats.org/drawingml/2006/main">
+            <a:off x="533400" y="742950"/>
+            <a:ext cx="11125200" cy="762000"/>
+          </a:xfrm>
+          <a:prstGeom xmlns:a="http://schemas.openxmlformats.org/drawingml/2006/main" prst="rect">
+            <a:avLst/>
+          </a:prstGeom>
+          <a:noFill xmlns:a="http://schemas.openxmlformats.org/drawingml/2006/main"/>
+          <a:ln xmlns:a="http://schemas.openxmlformats.org/drawingml/2006/main" w="0">
+            <a:noFill/>
+            <a:prstDash val="solid"/>
+          </a:ln>
+        </p:spPr>
+        <p:txBody>
+          <a:bodyPr xmlns:a="http://schemas.openxmlformats.org/drawingml/2006/main"/>
+          <a:lstStyle xmlns:a="http://schemas.openxmlformats.org/drawingml/2006/main"/>
+          <a:p xmlns:a="http://schemas.openxmlformats.org/drawingml/2006/main">
+            <a:pPr>
+              <a:defRPr sz="3150" b="1">
+                <a:solidFill>
+                  <a:srgbClr val="171717"/>
+                </a:solidFill>
+              </a:defRPr>
+            </a:pPr>
+            <a:r>
+              <a:rPr sz="3150" b="1">
+                <a:solidFill>
+                  <a:srgbClr val="171717"/>
+                </a:solidFill>
+              </a:rPr>
+              <a:t>Retrieve, diagnose, and validate governed evidence.</a:t>
+            </a:r>
+          </a:p>
+        </p:txBody>
+      </p:sp>
+      <p:sp>
+        <p:nvSpPr>
+          <p:cNvPr id="3" name="">
+            <a:extLst xmlns:a="http://schemas.openxmlformats.org/drawingml/2006/main">
+              <a:ext uri="{FF2B5EF4-FFF2-40B4-BE49-F238E27FC236}">
+                <a16:creationId xmlns:a16="http://schemas.microsoft.com/office/drawing/2014/main" id="{6330F432-7DEE-464E-9F1B-1DAB2D09E389}"/>
+              </a:ext>
+            </a:extLst>
+          </p:cNvPr>
+          <p:cNvSpPr>
+            <a:spLocks xmlns:a="http://schemas.openxmlformats.org/drawingml/2006/main" noGrp="1"/>
+          </p:cNvSpPr>
+          <p:nvPr/>
+        </p:nvSpPr>
+        <p:spPr>
+          <a:xfrm xmlns:a="http://schemas.openxmlformats.org/drawingml/2006/main">
+            <a:off x="533400" y="2047875"/>
+            <a:ext cx="3333750" cy="2524125"/>
+          </a:xfrm>
+          <a:prstGeom xmlns:a="http://schemas.openxmlformats.org/drawingml/2006/main" prst="roundRect">
+            <a:avLst>
+              <a:gd name="adj" fmla="val 3019"/>
+            </a:avLst>
+          </a:prstGeom>
+          <a:solidFill xmlns:a="http://schemas.openxmlformats.org/drawingml/2006/main">
+            <a:srgbClr val="FFFFFF"/>
+          </a:solidFill>
+          <a:ln xmlns:a="http://schemas.openxmlformats.org/drawingml/2006/main" w="9525">
+            <a:solidFill>
+              <a:srgbClr val="CCCCCC"/>
+            </a:solidFill>
+            <a:prstDash val="solid"/>
+          </a:ln>
+        </p:spPr>
+      </p:sp>
+      <p:sp>
+        <p:nvSpPr>
+          <p:cNvPr id="4" name="">
+            <a:extLst xmlns:a="http://schemas.openxmlformats.org/drawingml/2006/main">
+              <a:ext uri="{FF2B5EF4-FFF2-40B4-BE49-F238E27FC236}">
+                <a16:creationId xmlns:a16="http://schemas.microsoft.com/office/drawing/2014/main" id="{DF9EF2EE-846F-4857-9A90-92C8C48307AA}"/>
+              </a:ext>
+            </a:extLst>
+          </p:cNvPr>
+          <p:cNvSpPr>
+            <a:spLocks xmlns:a="http://schemas.openxmlformats.org/drawingml/2006/main" noGrp="1"/>
+          </p:cNvSpPr>
+          <p:nvPr/>
+        </p:nvSpPr>
+        <p:spPr>
+          <a:xfrm xmlns:a="http://schemas.openxmlformats.org/drawingml/2006/main">
+            <a:off x="742950" y="2286000"/>
+            <a:ext cx="2857500" cy="209550"/>
+          </a:xfrm>
+          <a:prstGeom xmlns:a="http://schemas.openxmlformats.org/drawingml/2006/main" prst="rect">
+            <a:avLst/>
+          </a:prstGeom>
+          <a:noFill xmlns:a="http://schemas.openxmlformats.org/drawingml/2006/main"/>
+          <a:ln xmlns:a="http://schemas.openxmlformats.org/drawingml/2006/main" w="0">
+            <a:noFill/>
+            <a:prstDash val="solid"/>
+          </a:ln>
+        </p:spPr>
+        <p:txBody>
+          <a:bodyPr xmlns:a="http://schemas.openxmlformats.org/drawingml/2006/main"/>
+          <a:lstStyle xmlns:a="http://schemas.openxmlformats.org/drawingml/2006/main"/>
+          <a:p xmlns:a="http://schemas.openxmlformats.org/drawingml/2006/main">
+            <a:pPr>
+              <a:defRPr sz="975" b="1">
+                <a:solidFill>
+                  <a:srgbClr val="D52B1E"/>
+                </a:solidFill>
+              </a:defRPr>
+            </a:pPr>
+            <a:r>
+              <a:rPr sz="975" b="1">
+                <a:solidFill>
+                  <a:srgbClr val="D52B1E"/>
+                </a:solidFill>
+              </a:rPr>
+              <a:t>CHATBOT</a:t>
+            </a:r>
+          </a:p>
+        </p:txBody>
+      </p:sp>
+      <p:sp>
+        <p:nvSpPr>
+          <p:cNvPr id="5" name="">
+            <a:extLst xmlns:a="http://schemas.openxmlformats.org/drawingml/2006/main">
+              <a:ext uri="{FF2B5EF4-FFF2-40B4-BE49-F238E27FC236}">
+                <a16:creationId xmlns:a16="http://schemas.microsoft.com/office/drawing/2014/main" id="{2CB40540-ECD3-48FB-B6BC-60725E260704}"/>
+              </a:ext>
+            </a:extLst>
+          </p:cNvPr>
+          <p:cNvSpPr>
+            <a:spLocks xmlns:a="http://schemas.openxmlformats.org/drawingml/2006/main" noGrp="1"/>
+          </p:cNvSpPr>
+          <p:nvPr/>
+        </p:nvSpPr>
+        <p:spPr>
+          <a:xfrm xmlns:a="http://schemas.openxmlformats.org/drawingml/2006/main">
+            <a:off x="742950" y="2781300"/>
+            <a:ext cx="2857500" cy="323850"/>
+          </a:xfrm>
+          <a:prstGeom xmlns:a="http://schemas.openxmlformats.org/drawingml/2006/main" prst="rect">
+            <a:avLst/>
+          </a:prstGeom>
+          <a:noFill xmlns:a="http://schemas.openxmlformats.org/drawingml/2006/main"/>
+          <a:ln xmlns:a="http://schemas.openxmlformats.org/drawingml/2006/main" w="0">
+            <a:noFill/>
+            <a:prstDash val="solid"/>
+          </a:ln>
+        </p:spPr>
+        <p:txBody>
+          <a:bodyPr xmlns:a="http://schemas.openxmlformats.org/drawingml/2006/main"/>
+          <a:lstStyle xmlns:a="http://schemas.openxmlformats.org/drawingml/2006/main"/>
+          <a:p xmlns:a="http://schemas.openxmlformats.org/drawingml/2006/main">
+            <a:pPr>
+              <a:defRPr sz="1650" b="1">
+                <a:solidFill>
+                  <a:srgbClr val="171717"/>
+                </a:solidFill>
+              </a:defRPr>
+            </a:pPr>
+            <a:r>
+              <a:rPr sz="1650" b="1">
+                <a:solidFill>
+                  <a:srgbClr val="171717"/>
+                </a:solidFill>
+              </a:rPr>
+              <a:t>Source-grounded retrieval</a:t>
+            </a:r>
+          </a:p>
+        </p:txBody>
+      </p:sp>
+      <p:sp>
+        <p:nvSpPr>
+          <p:cNvPr id="6" name="">
+            <a:extLst xmlns:a="http://schemas.openxmlformats.org/drawingml/2006/main">
+              <a:ext uri="{FF2B5EF4-FFF2-40B4-BE49-F238E27FC236}">
+                <a16:creationId xmlns:a16="http://schemas.microsoft.com/office/drawing/2014/main" id="{BF33E077-85A7-40D4-AA1B-A1E17CE776BF}"/>
+              </a:ext>
+            </a:extLst>
+          </p:cNvPr>
+          <p:cNvSpPr>
+            <a:spLocks xmlns:a="http://schemas.openxmlformats.org/drawingml/2006/main" noGrp="1"/>
+          </p:cNvSpPr>
+          <p:nvPr/>
+        </p:nvSpPr>
+        <p:spPr>
+          <a:xfrm xmlns:a="http://schemas.openxmlformats.org/drawingml/2006/main">
+            <a:off x="742950" y="3333750"/>
+            <a:ext cx="2857500" cy="495300"/>
+          </a:xfrm>
+          <a:prstGeom xmlns:a="http://schemas.openxmlformats.org/drawingml/2006/main" prst="rect">
+            <a:avLst/>
+          </a:prstGeom>
+          <a:noFill xmlns:a="http://schemas.openxmlformats.org/drawingml/2006/main"/>
+          <a:ln xmlns:a="http://schemas.openxmlformats.org/drawingml/2006/main" w="0">
+            <a:noFill/>
+            <a:prstDash val="solid"/>
+          </a:ln>
+        </p:spPr>
+        <p:txBody>
+          <a:bodyPr xmlns:a="http://schemas.openxmlformats.org/drawingml/2006/main"/>
+          <a:lstStyle xmlns:a="http://schemas.openxmlformats.org/drawingml/2006/main"/>
+          <a:p xmlns:a="http://schemas.openxmlformats.org/drawingml/2006/main">
+            <a:pPr>
+              <a:defRPr sz="1275" b="0">
+                <a:solidFill>
+                  <a:srgbClr val="626262"/>
+                </a:solidFill>
+              </a:defRPr>
+            </a:pPr>
+            <a:r>
+              <a:rPr sz="1275" b="0">
+                <a:solidFill>
+                  <a:srgbClr val="626262"/>
+                </a:solidFill>
+              </a:rPr>
+              <a:t>Validated citations · deterministic fallback</a:t>
+            </a:r>
+          </a:p>
+        </p:txBody>
+      </p:sp>
+      <p:sp>
+        <p:nvSpPr>
+          <p:cNvPr id="7" name="">
+            <a:extLst xmlns:a="http://schemas.openxmlformats.org/drawingml/2006/main">
+              <a:ext uri="{FF2B5EF4-FFF2-40B4-BE49-F238E27FC236}">
+                <a16:creationId xmlns:a16="http://schemas.microsoft.com/office/drawing/2014/main" id="{E32E4699-C315-4D6A-AC28-B0B495A7A676}"/>
+              </a:ext>
+            </a:extLst>
+          </p:cNvPr>
+          <p:cNvSpPr>
+            <a:spLocks xmlns:a="http://schemas.openxmlformats.org/drawingml/2006/main" noGrp="1"/>
+          </p:cNvSpPr>
+          <p:nvPr/>
+        </p:nvSpPr>
+        <p:spPr>
+          <a:xfrm xmlns:a="http://schemas.openxmlformats.org/drawingml/2006/main">
+            <a:off x="742950" y="4095750"/>
+            <a:ext cx="2857500" cy="228600"/>
+          </a:xfrm>
+          <a:prstGeom xmlns:a="http://schemas.openxmlformats.org/drawingml/2006/main" prst="rect">
+            <a:avLst/>
+          </a:prstGeom>
+          <a:noFill xmlns:a="http://schemas.openxmlformats.org/drawingml/2006/main"/>
+          <a:ln xmlns:a="http://schemas.openxmlformats.org/drawingml/2006/main" w="0">
+            <a:noFill/>
+            <a:prstDash val="solid"/>
+          </a:ln>
+        </p:spPr>
+        <p:txBody>
+          <a:bodyPr xmlns:a="http://schemas.openxmlformats.org/drawingml/2006/main"/>
+          <a:lstStyle xmlns:a="http://schemas.openxmlformats.org/drawingml/2006/main"/>
+          <a:p xmlns:a="http://schemas.openxmlformats.org/drawingml/2006/main">
+            <a:pPr>
+              <a:defRPr sz="1125" b="1">
+                <a:solidFill>
+                  <a:srgbClr val="D52B1E"/>
+                </a:solidFill>
+              </a:defRPr>
+            </a:pPr>
+            <a:r>
+              <a:rPr sz="1125" b="1">
+                <a:solidFill>
+                  <a:srgbClr val="D52B1E"/>
+                </a:solidFill>
+              </a:rPr>
+              <a:t>Estimated ~90% faster retrieval</a:t>
+            </a:r>
+          </a:p>
+        </p:txBody>
+      </p:sp>
+      <p:sp>
+        <p:nvSpPr>
+          <p:cNvPr id="8" name="">
+            <a:extLst xmlns:a="http://schemas.openxmlformats.org/drawingml/2006/main">
+              <a:ext uri="{FF2B5EF4-FFF2-40B4-BE49-F238E27FC236}">
+                <a16:creationId xmlns:a16="http://schemas.microsoft.com/office/drawing/2014/main" id="{18C99280-9FBB-4CBB-A5C4-1345F1DDDBDF}"/>
+              </a:ext>
+            </a:extLst>
+          </p:cNvPr>
+          <p:cNvSpPr>
+            <a:spLocks xmlns:a="http://schemas.openxmlformats.org/drawingml/2006/main" noGrp="1"/>
+          </p:cNvSpPr>
+          <p:nvPr/>
+        </p:nvSpPr>
+        <p:spPr>
+          <a:xfrm xmlns:a="http://schemas.openxmlformats.org/drawingml/2006/main">
+            <a:off x="4248150" y="2047875"/>
+            <a:ext cx="3333750" cy="2524125"/>
+          </a:xfrm>
+          <a:prstGeom xmlns:a="http://schemas.openxmlformats.org/drawingml/2006/main" prst="roundRect">
+            <a:avLst>
+              <a:gd name="adj" fmla="val 3019"/>
+            </a:avLst>
+          </a:prstGeom>
+          <a:solidFill xmlns:a="http://schemas.openxmlformats.org/drawingml/2006/main">
+            <a:srgbClr val="FFFFFF"/>
+          </a:solidFill>
+          <a:ln xmlns:a="http://schemas.openxmlformats.org/drawingml/2006/main" w="9525">
+            <a:solidFill>
+              <a:srgbClr val="CCCCCC"/>
+            </a:solidFill>
+            <a:prstDash val="solid"/>
+          </a:ln>
+        </p:spPr>
+      </p:sp>
+      <p:sp>
+        <p:nvSpPr>
+          <p:cNvPr id="9" name="">
+            <a:extLst xmlns:a="http://schemas.openxmlformats.org/drawingml/2006/main">
+              <a:ext uri="{FF2B5EF4-FFF2-40B4-BE49-F238E27FC236}">
+                <a16:creationId xmlns:a16="http://schemas.microsoft.com/office/drawing/2014/main" id="{2E40B19C-A0D5-4CC8-8B1B-8B2F4CE50554}"/>
+              </a:ext>
+            </a:extLst>
+          </p:cNvPr>
+          <p:cNvSpPr>
+            <a:spLocks xmlns:a="http://schemas.openxmlformats.org/drawingml/2006/main" noGrp="1"/>
+          </p:cNvSpPr>
+          <p:nvPr/>
+        </p:nvSpPr>
+        <p:spPr>
+          <a:xfrm xmlns:a="http://schemas.openxmlformats.org/drawingml/2006/main">
+            <a:off x="4457700" y="2286000"/>
+            <a:ext cx="2857500" cy="209550"/>
+          </a:xfrm>
+          <a:prstGeom xmlns:a="http://schemas.openxmlformats.org/drawingml/2006/main" prst="rect">
+            <a:avLst/>
+          </a:prstGeom>
+          <a:noFill xmlns:a="http://schemas.openxmlformats.org/drawingml/2006/main"/>
+          <a:ln xmlns:a="http://schemas.openxmlformats.org/drawingml/2006/main" w="0">
+            <a:noFill/>
+            <a:prstDash val="solid"/>
+          </a:ln>
+        </p:spPr>
+        <p:txBody>
+          <a:bodyPr xmlns:a="http://schemas.openxmlformats.org/drawingml/2006/main"/>
+          <a:lstStyle xmlns:a="http://schemas.openxmlformats.org/drawingml/2006/main"/>
+          <a:p xmlns:a="http://schemas.openxmlformats.org/drawingml/2006/main">
+            <a:pPr>
+              <a:defRPr sz="975" b="1">
+                <a:solidFill>
+                  <a:srgbClr val="D52B1E"/>
+                </a:solidFill>
+              </a:defRPr>
+            </a:pPr>
+            <a:r>
+              <a:rPr sz="975" b="1">
+                <a:solidFill>
+                  <a:srgbClr val="D52B1E"/>
+                </a:solidFill>
+              </a:rPr>
+              <a:t>REPORT DOCTOR</a:t>
+            </a:r>
+          </a:p>
+        </p:txBody>
+      </p:sp>
+      <p:sp>
+        <p:nvSpPr>
+          <p:cNvPr id="10" name="">
+            <a:extLst xmlns:a="http://schemas.openxmlformats.org/drawingml/2006/main">
+              <a:ext uri="{FF2B5EF4-FFF2-40B4-BE49-F238E27FC236}">
+                <a16:creationId xmlns:a16="http://schemas.microsoft.com/office/drawing/2014/main" id="{D9EC4FE9-FDAD-4A2A-B34E-0A6C97BBB1F2}"/>
+              </a:ext>
+            </a:extLst>
+          </p:cNvPr>
+          <p:cNvSpPr>
+            <a:spLocks xmlns:a="http://schemas.openxmlformats.org/drawingml/2006/main" noGrp="1"/>
+          </p:cNvSpPr>
+          <p:nvPr/>
+        </p:nvSpPr>
+        <p:spPr>
+          <a:xfrm xmlns:a="http://schemas.openxmlformats.org/drawingml/2006/main">
+            <a:off x="4457700" y="2781300"/>
+            <a:ext cx="2857500" cy="323850"/>
+          </a:xfrm>
+          <a:prstGeom xmlns:a="http://schemas.openxmlformats.org/drawingml/2006/main" prst="rect">
+            <a:avLst/>
+          </a:prstGeom>
+          <a:noFill xmlns:a="http://schemas.openxmlformats.org/drawingml/2006/main"/>
+          <a:ln xmlns:a="http://schemas.openxmlformats.org/drawingml/2006/main" w="0">
+            <a:noFill/>
+            <a:prstDash val="solid"/>
+          </a:ln>
+        </p:spPr>
+        <p:txBody>
+          <a:bodyPr xmlns:a="http://schemas.openxmlformats.org/drawingml/2006/main"/>
+          <a:lstStyle xmlns:a="http://schemas.openxmlformats.org/drawingml/2006/main"/>
+          <a:p xmlns:a="http://schemas.openxmlformats.org/drawingml/2006/main">
+            <a:pPr>
+              <a:defRPr sz="1650" b="1">
+                <a:solidFill>
+                  <a:srgbClr val="171717"/>
+                </a:solidFill>
+              </a:defRPr>
+            </a:pPr>
+            <a:r>
+              <a:rPr sz="1650" b="1">
+                <a:solidFill>
+                  <a:srgbClr val="171717"/>
+                </a:solidFill>
+              </a:rPr>
+              <a:t>Read-only diagnostics</a:t>
+            </a:r>
+          </a:p>
+        </p:txBody>
+      </p:sp>
+      <p:sp>
+        <p:nvSpPr>
+          <p:cNvPr id="11" name="">
+            <a:extLst xmlns:a="http://schemas.openxmlformats.org/drawingml/2006/main">
+              <a:ext uri="{FF2B5EF4-FFF2-40B4-BE49-F238E27FC236}">
+                <a16:creationId xmlns:a16="http://schemas.microsoft.com/office/drawing/2014/main" id="{CAB41CCB-6F87-4425-89D6-85FA7EBC146C}"/>
+              </a:ext>
+            </a:extLst>
+          </p:cNvPr>
+          <p:cNvSpPr>
+            <a:spLocks xmlns:a="http://schemas.openxmlformats.org/drawingml/2006/main" noGrp="1"/>
+          </p:cNvSpPr>
+          <p:nvPr/>
+        </p:nvSpPr>
+        <p:spPr>
+          <a:xfrm xmlns:a="http://schemas.openxmlformats.org/drawingml/2006/main">
+            <a:off x="4457700" y="3333750"/>
+            <a:ext cx="2857500" cy="495300"/>
+          </a:xfrm>
+          <a:prstGeom xmlns:a="http://schemas.openxmlformats.org/drawingml/2006/main" prst="rect">
+            <a:avLst/>
+          </a:prstGeom>
+          <a:noFill xmlns:a="http://schemas.openxmlformats.org/drawingml/2006/main"/>
+          <a:ln xmlns:a="http://schemas.openxmlformats.org/drawingml/2006/main" w="0">
+            <a:noFill/>
+            <a:prstDash val="solid"/>
+          </a:ln>
+        </p:spPr>
+        <p:txBody>
+          <a:bodyPr xmlns:a="http://schemas.openxmlformats.org/drawingml/2006/main"/>
+          <a:lstStyle xmlns:a="http://schemas.openxmlformats.org/drawingml/2006/main"/>
+          <a:p xmlns:a="http://schemas.openxmlformats.org/drawingml/2006/main">
+            <a:pPr>
+              <a:defRPr sz="1275" b="0">
+                <a:solidFill>
+                  <a:srgbClr val="626262"/>
+                </a:solidFill>
+              </a:defRPr>
+            </a:pPr>
+            <a:r>
+              <a:rPr sz="1275" b="0">
+                <a:solidFill>
+                  <a:srgbClr val="626262"/>
+                </a:solidFill>
+              </a:rPr>
+              <a:t>Expected outputs · exceptions · settlement</a:t>
+            </a:r>
+          </a:p>
+        </p:txBody>
+      </p:sp>
+      <p:sp>
+        <p:nvSpPr>
+          <p:cNvPr id="12" name="">
+            <a:extLst xmlns:a="http://schemas.openxmlformats.org/drawingml/2006/main">
+              <a:ext uri="{FF2B5EF4-FFF2-40B4-BE49-F238E27FC236}">
+                <a16:creationId xmlns:a16="http://schemas.microsoft.com/office/drawing/2014/main" id="{D60EF068-2F7A-450F-9E90-F977C0394565}"/>
+              </a:ext>
+            </a:extLst>
+          </p:cNvPr>
+          <p:cNvSpPr>
+            <a:spLocks xmlns:a="http://schemas.openxmlformats.org/drawingml/2006/main" noGrp="1"/>
+          </p:cNvSpPr>
+          <p:nvPr/>
+        </p:nvSpPr>
+        <p:spPr>
+          <a:xfrm xmlns:a="http://schemas.openxmlformats.org/drawingml/2006/main">
+            <a:off x="4457700" y="4095750"/>
+            <a:ext cx="2857500" cy="228600"/>
+          </a:xfrm>
+          <a:prstGeom xmlns:a="http://schemas.openxmlformats.org/drawingml/2006/main" prst="rect">
+            <a:avLst/>
+          </a:prstGeom>
+          <a:noFill xmlns:a="http://schemas.openxmlformats.org/drawingml/2006/main"/>
+          <a:ln xmlns:a="http://schemas.openxmlformats.org/drawingml/2006/main" w="0">
+            <a:noFill/>
+            <a:prstDash val="solid"/>
+          </a:ln>
+        </p:spPr>
+        <p:txBody>
+          <a:bodyPr xmlns:a="http://schemas.openxmlformats.org/drawingml/2006/main"/>
+          <a:lstStyle xmlns:a="http://schemas.openxmlformats.org/drawingml/2006/main"/>
+          <a:p xmlns:a="http://schemas.openxmlformats.org/drawingml/2006/main">
+            <a:pPr>
+              <a:defRPr sz="1125" b="1">
+                <a:solidFill>
+                  <a:srgbClr val="D52B1E"/>
+                </a:solidFill>
+              </a:defRPr>
+            </a:pPr>
+            <a:r>
+              <a:rPr sz="1125" b="1">
+                <a:solidFill>
+                  <a:srgbClr val="D52B1E"/>
+                </a:solidFill>
+              </a:rPr>
+              <a:t>Observe without mutation</a:t>
+            </a:r>
+          </a:p>
+        </p:txBody>
+      </p:sp>
+      <p:sp>
+        <p:nvSpPr>
+          <p:cNvPr id="13" name="">
+            <a:extLst xmlns:a="http://schemas.openxmlformats.org/drawingml/2006/main">
+              <a:ext uri="{FF2B5EF4-FFF2-40B4-BE49-F238E27FC236}">
+                <a16:creationId xmlns:a16="http://schemas.microsoft.com/office/drawing/2014/main" id="{7CF75272-4184-4EE4-B4C2-DC94FCB7F409}"/>
+              </a:ext>
+            </a:extLst>
+          </p:cNvPr>
+          <p:cNvSpPr>
+            <a:spLocks xmlns:a="http://schemas.openxmlformats.org/drawingml/2006/main" noGrp="1"/>
+          </p:cNvSpPr>
+          <p:nvPr/>
+        </p:nvSpPr>
+        <p:spPr>
+          <a:xfrm xmlns:a="http://schemas.openxmlformats.org/drawingml/2006/main">
+            <a:off x="7962900" y="2047875"/>
+            <a:ext cx="3333750" cy="2524125"/>
+          </a:xfrm>
+          <a:prstGeom xmlns:a="http://schemas.openxmlformats.org/drawingml/2006/main" prst="roundRect">
+            <a:avLst>
+              <a:gd name="adj" fmla="val 3019"/>
+            </a:avLst>
+          </a:prstGeom>
+          <a:solidFill xmlns:a="http://schemas.openxmlformats.org/drawingml/2006/main">
+            <a:srgbClr val="171717"/>
+          </a:solidFill>
+          <a:ln xmlns:a="http://schemas.openxmlformats.org/drawingml/2006/main" w="9525">
+            <a:solidFill>
+              <a:srgbClr val="171717"/>
+            </a:solidFill>
+            <a:prstDash val="solid"/>
+          </a:ln>
+        </p:spPr>
+      </p:sp>
+      <p:sp>
+        <p:nvSpPr>
+          <p:cNvPr id="14" name="">
+            <a:extLst xmlns:a="http://schemas.openxmlformats.org/drawingml/2006/main">
+              <a:ext uri="{FF2B5EF4-FFF2-40B4-BE49-F238E27FC236}">
+                <a16:creationId xmlns:a16="http://schemas.microsoft.com/office/drawing/2014/main" id="{F8FA4D18-D0E5-47BD-BB20-6EB6A02A9F4E}"/>
+              </a:ext>
+            </a:extLst>
+          </p:cNvPr>
+          <p:cNvSpPr>
+            <a:spLocks xmlns:a="http://schemas.openxmlformats.org/drawingml/2006/main" noGrp="1"/>
+          </p:cNvSpPr>
+          <p:nvPr/>
+        </p:nvSpPr>
+        <p:spPr>
+          <a:xfrm xmlns:a="http://schemas.openxmlformats.org/drawingml/2006/main">
+            <a:off x="8172450" y="2286000"/>
+            <a:ext cx="2857500" cy="209550"/>
+          </a:xfrm>
+          <a:prstGeom xmlns:a="http://schemas.openxmlformats.org/drawingml/2006/main" prst="rect">
+            <a:avLst/>
+          </a:prstGeom>
+          <a:noFill xmlns:a="http://schemas.openxmlformats.org/drawingml/2006/main"/>
+          <a:ln xmlns:a="http://schemas.openxmlformats.org/drawingml/2006/main" w="0">
+            <a:noFill/>
+            <a:prstDash val="solid"/>
+          </a:ln>
+        </p:spPr>
+        <p:txBody>
+          <a:bodyPr xmlns:a="http://schemas.openxmlformats.org/drawingml/2006/main"/>
+          <a:lstStyle xmlns:a="http://schemas.openxmlformats.org/drawingml/2006/main"/>
+          <a:p xmlns:a="http://schemas.openxmlformats.org/drawingml/2006/main">
+            <a:pPr>
+              <a:defRPr sz="975" b="1">
+                <a:solidFill>
+                  <a:srgbClr val="FF6A60"/>
+                </a:solidFill>
+              </a:defRPr>
+            </a:pPr>
+            <a:r>
+              <a:rPr sz="975" b="1">
+                <a:solidFill>
+                  <a:srgbClr val="FF6A60"/>
+                </a:solidFill>
+              </a:rPr>
+              <a:t>GOVERNED ORACLE</a:t>
+            </a:r>
+          </a:p>
+        </p:txBody>
+      </p:sp>
+      <p:sp>
+        <p:nvSpPr>
+          <p:cNvPr id="15" name="">
+            <a:extLst xmlns:a="http://schemas.openxmlformats.org/drawingml/2006/main">
+              <a:ext uri="{FF2B5EF4-FFF2-40B4-BE49-F238E27FC236}">
+                <a16:creationId xmlns:a16="http://schemas.microsoft.com/office/drawing/2014/main" id="{FBB89A5D-FE68-4F4F-A3E7-B1C496CCDF9B}"/>
+              </a:ext>
+            </a:extLst>
+          </p:cNvPr>
+          <p:cNvSpPr>
+            <a:spLocks xmlns:a="http://schemas.openxmlformats.org/drawingml/2006/main" noGrp="1"/>
+          </p:cNvSpPr>
+          <p:nvPr/>
+        </p:nvSpPr>
+        <p:spPr>
+          <a:xfrm xmlns:a="http://schemas.openxmlformats.org/drawingml/2006/main">
+            <a:off x="8172450" y="2781300"/>
+            <a:ext cx="2857500" cy="323850"/>
+          </a:xfrm>
+          <a:prstGeom xmlns:a="http://schemas.openxmlformats.org/drawingml/2006/main" prst="rect">
+            <a:avLst/>
+          </a:prstGeom>
+          <a:noFill xmlns:a="http://schemas.openxmlformats.org/drawingml/2006/main"/>
+          <a:ln xmlns:a="http://schemas.openxmlformats.org/drawingml/2006/main" w="0">
+            <a:noFill/>
+            <a:prstDash val="solid"/>
+          </a:ln>
+        </p:spPr>
+        <p:txBody>
+          <a:bodyPr xmlns:a="http://schemas.openxmlformats.org/drawingml/2006/main"/>
+          <a:lstStyle xmlns:a="http://schemas.openxmlformats.org/drawingml/2006/main"/>
+          <a:p xmlns:a="http://schemas.openxmlformats.org/drawingml/2006/main">
+            <a:pPr>
+              <a:defRPr sz="1650" b="1">
+                <a:solidFill>
+                  <a:srgbClr val="FFFFFF"/>
+                </a:solidFill>
+              </a:defRPr>
+            </a:pPr>
+            <a:r>
+              <a:rPr sz="1650" b="1">
+                <a:solidFill>
+                  <a:srgbClr val="FFFFFF"/>
+                </a:solidFill>
+              </a:rPr>
+              <a:t>Contract-bound validation</a:t>
+            </a:r>
+          </a:p>
+        </p:txBody>
+      </p:sp>
+      <p:sp>
+        <p:nvSpPr>
+          <p:cNvPr id="16" name="">
+            <a:extLst xmlns:a="http://schemas.openxmlformats.org/drawingml/2006/main">
+              <a:ext uri="{FF2B5EF4-FFF2-40B4-BE49-F238E27FC236}">
+                <a16:creationId xmlns:a16="http://schemas.microsoft.com/office/drawing/2014/main" id="{F0986F00-DA2A-4F13-BA4C-26D4DFAAAA50}"/>
+              </a:ext>
+            </a:extLst>
+          </p:cNvPr>
+          <p:cNvSpPr>
+            <a:spLocks xmlns:a="http://schemas.openxmlformats.org/drawingml/2006/main" noGrp="1"/>
+          </p:cNvSpPr>
+          <p:nvPr/>
+        </p:nvSpPr>
+        <p:spPr>
+          <a:xfrm xmlns:a="http://schemas.openxmlformats.org/drawingml/2006/main">
+            <a:off x="8172450" y="3333750"/>
+            <a:ext cx="2857500" cy="495300"/>
+          </a:xfrm>
+          <a:prstGeom xmlns:a="http://schemas.openxmlformats.org/drawingml/2006/main" prst="rect">
+            <a:avLst/>
+          </a:prstGeom>
+          <a:noFill xmlns:a="http://schemas.openxmlformats.org/drawingml/2006/main"/>
+          <a:ln xmlns:a="http://schemas.openxmlformats.org/drawingml/2006/main" w="0">
+            <a:noFill/>
+            <a:prstDash val="solid"/>
+          </a:ln>
+        </p:spPr>
+        <p:txBody>
+          <a:bodyPr xmlns:a="http://schemas.openxmlformats.org/drawingml/2006/main"/>
+          <a:lstStyle xmlns:a="http://schemas.openxmlformats.org/drawingml/2006/main"/>
+          <a:p xmlns:a="http://schemas.openxmlformats.org/drawingml/2006/main">
+            <a:pPr>
+              <a:defRPr sz="1275" b="0">
+                <a:solidFill>
+                  <a:srgbClr val="BBBBBB"/>
+                </a:solidFill>
+              </a:defRPr>
+            </a:pPr>
+            <a:r>
+              <a:rPr sz="1275" b="0">
+                <a:solidFill>
+                  <a:srgbClr val="BBBBBB"/>
+                </a:solidFill>
+              </a:rPr>
+              <a:t>Identity · lineage · state · semantics</a:t>
+            </a:r>
+          </a:p>
+        </p:txBody>
+      </p:sp>
+      <p:sp>
+        <p:nvSpPr>
+          <p:cNvPr id="17" name="">
+            <a:extLst xmlns:a="http://schemas.openxmlformats.org/drawingml/2006/main">
+              <a:ext uri="{FF2B5EF4-FFF2-40B4-BE49-F238E27FC236}">
+                <a16:creationId xmlns:a16="http://schemas.microsoft.com/office/drawing/2014/main" id="{9DFA5E0F-2EE5-4B24-875D-99A4E03673AC}"/>
+              </a:ext>
+            </a:extLst>
+          </p:cNvPr>
+          <p:cNvSpPr>
+            <a:spLocks xmlns:a="http://schemas.openxmlformats.org/drawingml/2006/main" noGrp="1"/>
+          </p:cNvSpPr>
+          <p:nvPr/>
+        </p:nvSpPr>
+        <p:spPr>
+          <a:xfrm xmlns:a="http://schemas.openxmlformats.org/drawingml/2006/main">
+            <a:off x="8172450" y="4095750"/>
+            <a:ext cx="2857500" cy="228600"/>
+          </a:xfrm>
+          <a:prstGeom xmlns:a="http://schemas.openxmlformats.org/drawingml/2006/main" prst="rect">
+            <a:avLst/>
+          </a:prstGeom>
+          <a:noFill xmlns:a="http://schemas.openxmlformats.org/drawingml/2006/main"/>
+          <a:ln xmlns:a="http://schemas.openxmlformats.org/drawingml/2006/main" w="0">
+            <a:noFill/>
+            <a:prstDash val="solid"/>
+          </a:ln>
+        </p:spPr>
+        <p:txBody>
+          <a:bodyPr xmlns:a="http://schemas.openxmlformats.org/drawingml/2006/main"/>
+          <a:lstStyle xmlns:a="http://schemas.openxmlformats.org/drawingml/2006/main"/>
+          <a:p xmlns:a="http://schemas.openxmlformats.org/drawingml/2006/main">
+            <a:pPr>
+              <a:defRPr sz="1125" b="1">
+                <a:solidFill>
+                  <a:srgbClr val="FFFFFF"/>
+                </a:solidFill>
+              </a:defRPr>
+            </a:pPr>
+            <a:r>
+              <a:rPr sz="1125" b="1">
+                <a:solidFill>
+                  <a:srgbClr val="FFFFFF"/>
+                </a:solidFill>
+              </a:rPr>
+              <a:t>Missing evidence fails closed</a:t>
+            </a:r>
+          </a:p>
+        </p:txBody>
+      </p:sp>
+      <p:sp>
+        <p:nvSpPr>
+          <p:cNvPr id="18" name="">
+            <a:extLst xmlns:a="http://schemas.openxmlformats.org/drawingml/2006/main">
+              <a:ext uri="{FF2B5EF4-FFF2-40B4-BE49-F238E27FC236}">
+                <a16:creationId xmlns:a16="http://schemas.microsoft.com/office/drawing/2014/main" id="{520FACF8-546B-4E32-9BA0-D60A3C88E72B}"/>
+              </a:ext>
+            </a:extLst>
+          </p:cNvPr>
+          <p:cNvSpPr>
+            <a:spLocks xmlns:a="http://schemas.openxmlformats.org/drawingml/2006/main" noGrp="1"/>
+          </p:cNvSpPr>
+          <p:nvPr/>
+        </p:nvSpPr>
+        <p:spPr>
+          <a:xfrm xmlns:a="http://schemas.openxmlformats.org/drawingml/2006/main">
+            <a:off x="533400" y="4953000"/>
+            <a:ext cx="10744200" cy="685800"/>
+          </a:xfrm>
+          <a:prstGeom xmlns:a="http://schemas.openxmlformats.org/drawingml/2006/main" prst="roundRect">
+            <a:avLst>
+              <a:gd name="adj" fmla="val 11111"/>
+            </a:avLst>
+          </a:prstGeom>
+          <a:solidFill xmlns:a="http://schemas.openxmlformats.org/drawingml/2006/main">
+            <a:srgbClr val="FBE8E6"/>
+          </a:solidFill>
+          <a:ln xmlns:a="http://schemas.openxmlformats.org/drawingml/2006/main" w="9525">
+            <a:solidFill>
+              <a:srgbClr val="D52B1E"/>
+            </a:solidFill>
+            <a:prstDash val="solid"/>
+          </a:ln>
+        </p:spPr>
+      </p:sp>
+      <p:sp>
+        <p:nvSpPr>
+          <p:cNvPr id="19" name="">
+            <a:extLst xmlns:a="http://schemas.openxmlformats.org/drawingml/2006/main">
+              <a:ext uri="{FF2B5EF4-FFF2-40B4-BE49-F238E27FC236}">
+                <a16:creationId xmlns:a16="http://schemas.microsoft.com/office/drawing/2014/main" id="{7891B383-A9FF-4758-BB57-EE1FD552C6A0}"/>
+              </a:ext>
+            </a:extLst>
+          </p:cNvPr>
+          <p:cNvSpPr>
+            <a:spLocks xmlns:a="http://schemas.openxmlformats.org/drawingml/2006/main" noGrp="1"/>
+          </p:cNvSpPr>
+          <p:nvPr/>
+        </p:nvSpPr>
+        <p:spPr>
+          <a:xfrm xmlns:a="http://schemas.openxmlformats.org/drawingml/2006/main">
+            <a:off x="742950" y="5181600"/>
+            <a:ext cx="10325100" cy="266700"/>
+          </a:xfrm>
+          <a:prstGeom xmlns:a="http://schemas.openxmlformats.org/drawingml/2006/main" prst="rect">
+            <a:avLst/>
+          </a:prstGeom>
+          <a:noFill xmlns:a="http://schemas.openxmlformats.org/drawingml/2006/main"/>
+          <a:ln xmlns:a="http://schemas.openxmlformats.org/drawingml/2006/main" w="0">
+            <a:noFill/>
+            <a:prstDash val="solid"/>
+          </a:ln>
+        </p:spPr>
+        <p:txBody>
+          <a:bodyPr xmlns:a="http://schemas.openxmlformats.org/drawingml/2006/main"/>
+          <a:lstStyle xmlns:a="http://schemas.openxmlformats.org/drawingml/2006/main"/>
+          <a:p xmlns:a="http://schemas.openxmlformats.org/drawingml/2006/main">
+            <a:pPr>
+              <a:defRPr sz="1275" b="1">
+                <a:solidFill>
+                  <a:srgbClr val="171717"/>
+                </a:solidFill>
+              </a:defRPr>
+            </a:pPr>
+            <a:r>
+              <a:rPr sz="1275" b="1">
+                <a:solidFill>
+                  <a:srgbClr val="171717"/>
+                </a:solidFill>
+              </a:rPr>
+              <a:t>Secondary model: up to 227.5K widgets / approximately $205K contribution-margin opportunity under documented assumptions.</a:t>
+            </a:r>
+          </a:p>
+        </p:txBody>
+      </p:sp>
+      <p:sp>
+        <p:nvSpPr>
+          <p:cNvPr id="20" name="">
+            <a:extLst xmlns:a="http://schemas.openxmlformats.org/drawingml/2006/main">
+              <a:ext uri="{FF2B5EF4-FFF2-40B4-BE49-F238E27FC236}">
+                <a16:creationId xmlns:a16="http://schemas.microsoft.com/office/drawing/2014/main" id="{D320E1FC-673C-4982-8F6B-064F50817077}"/>
+              </a:ext>
+            </a:extLst>
+          </p:cNvPr>
+          <p:cNvSpPr>
+            <a:spLocks xmlns:a="http://schemas.openxmlformats.org/drawingml/2006/main" noGrp="1"/>
+          </p:cNvSpPr>
+          <p:nvPr/>
+        </p:nvSpPr>
+        <p:spPr>
+          <a:xfrm xmlns:a="http://schemas.openxmlformats.org/drawingml/2006/main">
+            <a:off x="533400" y="6429375"/>
+            <a:ext cx="6858000" cy="171450"/>
+          </a:xfrm>
+          <a:prstGeom xmlns:a="http://schemas.openxmlformats.org/drawingml/2006/main" prst="rect">
+            <a:avLst/>
+          </a:prstGeom>
+          <a:noFill xmlns:a="http://schemas.openxmlformats.org/drawingml/2006/main"/>
+          <a:ln xmlns:a="http://schemas.openxmlformats.org/drawingml/2006/main" w="0">
+            <a:noFill/>
+            <a:prstDash val="solid"/>
+          </a:ln>
+        </p:spPr>
+        <p:txBody>
+          <a:bodyPr xmlns:a="http://schemas.openxmlformats.org/drawingml/2006/main"/>
+          <a:lstStyle xmlns:a="http://schemas.openxmlformats.org/drawingml/2006/main"/>
+          <a:p xmlns:a="http://schemas.openxmlformats.org/drawingml/2006/main">
+            <a:pPr>
+              <a:defRPr sz="825" b="1">
+                <a:solidFill>
+                  <a:srgbClr val="626262"/>
+                </a:solidFill>
+              </a:defRPr>
+            </a:pPr>
+            <a:r>
+              <a:rPr sz="825" b="1">
+                <a:solidFill>
+                  <a:srgbClr val="626262"/>
+                </a:solidFill>
+              </a:rPr>
+              <a:t>THOMAS RYAN  |  MANUFACTURING REPORTING PLATFORM</a:t>
+            </a:r>
+          </a:p>
+        </p:txBody>
+      </p:sp>
+    </p:spTree>
+    <p:extLst>
+      <p:ext uri="{BB962C8B-B14F-4D97-AF65-F5344CB8AC3E}">
+        <p14:creationId xmlns:p14="http://schemas.microsoft.com/office/powerpoint/2010/main" val="755376282"/>
       </p:ext>
     </p:extLst>
   </p:cSld>

</xml_diff>

<commit_message>
Clarify reporting assistant and viewer journey
</commit_message>
<xml_diff>
--- a/public/Thomas-Ryan-PepperBall-Platform-Case-Study.pptx
+++ b/public/Thomas-Ryan-PepperBall-Platform-Case-Study.pptx
@@ -2,19 +2,19 @@
 <file path=ppt/presentation.xml><?xml version="1.0" encoding="utf-8"?>
 <p:presentation xmlns:p="http://schemas.openxmlformats.org/presentationml/2006/main">
   <p:sldMasterIdLst>
-    <p:sldMasterId xmlns:r="http://schemas.openxmlformats.org/officeDocument/2006/relationships" id="2147483648" r:id="R21af0170ae124600"/>
+    <p:sldMasterId xmlns:r="http://schemas.openxmlformats.org/officeDocument/2006/relationships" id="2147483648" r:id="Ree92946b0015403e"/>
   </p:sldMasterIdLst>
   <p:notesMasterIdLst>
-    <p:notesMasterId xmlns:r="http://schemas.openxmlformats.org/officeDocument/2006/relationships" r:id="R178e92778c2d48ea"/>
+    <p:notesMasterId xmlns:r="http://schemas.openxmlformats.org/officeDocument/2006/relationships" r:id="R19b7c41849e644e6"/>
   </p:notesMasterIdLst>
   <p:sldIdLst>
-    <p:sldId xmlns:r="http://schemas.openxmlformats.org/officeDocument/2006/relationships" id="256" r:id="Ra6941c86f7b14a81"/>
-    <p:sldId xmlns:r="http://schemas.openxmlformats.org/officeDocument/2006/relationships" id="257" r:id="R90a0d324902f4c78"/>
-    <p:sldId xmlns:r="http://schemas.openxmlformats.org/officeDocument/2006/relationships" id="258" r:id="Rdbf8bead0ff44896"/>
-    <p:sldId xmlns:r="http://schemas.openxmlformats.org/officeDocument/2006/relationships" id="259" r:id="R2c38a20d18ba44db"/>
-    <p:sldId xmlns:r="http://schemas.openxmlformats.org/officeDocument/2006/relationships" id="260" r:id="Rdbb9dd8f516442d9"/>
-    <p:sldId xmlns:r="http://schemas.openxmlformats.org/officeDocument/2006/relationships" id="261" r:id="Rc24422b527b54988"/>
-    <p:sldId xmlns:r="http://schemas.openxmlformats.org/officeDocument/2006/relationships" id="262" r:id="R86d8cd3ec7064d02"/>
+    <p:sldId xmlns:r="http://schemas.openxmlformats.org/officeDocument/2006/relationships" id="256" r:id="R76356d9bdb7a4031"/>
+    <p:sldId xmlns:r="http://schemas.openxmlformats.org/officeDocument/2006/relationships" id="257" r:id="Rdf5ca53460c74f90"/>
+    <p:sldId xmlns:r="http://schemas.openxmlformats.org/officeDocument/2006/relationships" id="258" r:id="Ra7f5dfa04aa44f3c"/>
+    <p:sldId xmlns:r="http://schemas.openxmlformats.org/officeDocument/2006/relationships" id="259" r:id="R42f0114ee4b04205"/>
+    <p:sldId xmlns:r="http://schemas.openxmlformats.org/officeDocument/2006/relationships" id="260" r:id="R1ae94cfb07934667"/>
+    <p:sldId xmlns:r="http://schemas.openxmlformats.org/officeDocument/2006/relationships" id="261" r:id="R14f2c0d508e64123"/>
+    <p:sldId xmlns:r="http://schemas.openxmlformats.org/officeDocument/2006/relationships" id="262" r:id="Rfc6a5a81a1b944e2"/>
   </p:sldIdLst>
   <p:sldSz cx="12192000" cy="6858000"/>
   <p:notesSz cx="6858000" cy="9144000"/>
@@ -1041,7 +1041,7 @@
   </p:cSld>
   <p:clrMap bg1="lt1" tx1="dk1" bg2="lt2" tx2="dk2" accent1="accent1" accent2="accent2" accent3="accent3" accent4="accent4" accent5="accent5" accent6="accent6" hlink="hlink" folHlink="folHlink"/>
   <p:sldLayoutIdLst>
-    <p:sldLayoutId xmlns:r="http://schemas.openxmlformats.org/officeDocument/2006/relationships" id="2147483649" r:id="R2da40aa2dce744b0"/>
+    <p:sldLayoutId xmlns:r="http://schemas.openxmlformats.org/officeDocument/2006/relationships" id="2147483649" r:id="Rdb92bb3f7cac4dfe"/>
   </p:sldLayoutIdLst>
   <p:txStyles>
     <p:titleStyle>
@@ -1620,6 +1620,7 @@
           <a:lstStyle xmlns:a="http://schemas.openxmlformats.org/drawingml/2006/main"/>
           <a:p xmlns:a="http://schemas.openxmlformats.org/drawingml/2006/main">
             <a:pPr algn="l">
+              <a:buNone/>
               <a:defRPr sz="4200" b="1">
                 <a:solidFill>
                   <a:srgbClr val="171717"/>
@@ -1637,6 +1638,7 @@
           </a:p>
           <a:p xmlns:a="http://schemas.openxmlformats.org/drawingml/2006/main">
             <a:pPr algn="l">
+              <a:buNone/>
               <a:defRPr sz="4200" b="1">
                 <a:solidFill>
                   <a:srgbClr val="171717"/>
@@ -1654,6 +1656,7 @@
           </a:p>
           <a:p xmlns:a="http://schemas.openxmlformats.org/drawingml/2006/main">
             <a:pPr algn="l">
+              <a:buNone/>
               <a:defRPr sz="4200" b="1">
                 <a:solidFill>
                   <a:srgbClr val="171717"/>
@@ -1735,6 +1738,7 @@
           <a:lstStyle xmlns:a="http://schemas.openxmlformats.org/drawingml/2006/main"/>
           <a:p xmlns:a="http://schemas.openxmlformats.org/drawingml/2006/main">
             <a:pPr algn="l">
+              <a:buNone/>
               <a:defRPr sz="1650" b="0">
                 <a:solidFill>
                   <a:srgbClr val="626262"/>
@@ -1785,6 +1789,7 @@
           <a:lstStyle xmlns:a="http://schemas.openxmlformats.org/drawingml/2006/main"/>
           <a:p xmlns:a="http://schemas.openxmlformats.org/drawingml/2006/main">
             <a:pPr algn="l">
+              <a:buNone/>
               <a:defRPr sz="900" b="1">
                 <a:solidFill>
                   <a:srgbClr val="D52B1E"/>
@@ -1864,6 +1869,7 @@
           <a:lstStyle xmlns:a="http://schemas.openxmlformats.org/drawingml/2006/main"/>
           <a:p xmlns:a="http://schemas.openxmlformats.org/drawingml/2006/main">
             <a:pPr algn="l">
+              <a:buNone/>
               <a:defRPr sz="1050" b="1">
                 <a:solidFill>
                   <a:srgbClr val="D52B1E"/>
@@ -1914,6 +1920,7 @@
           <a:lstStyle xmlns:a="http://schemas.openxmlformats.org/drawingml/2006/main"/>
           <a:p xmlns:a="http://schemas.openxmlformats.org/drawingml/2006/main">
             <a:pPr algn="l">
+              <a:buNone/>
               <a:defRPr sz="825" b="1">
                 <a:solidFill>
                   <a:srgbClr val="626262"/>
@@ -1964,6 +1971,7 @@
           <a:lstStyle xmlns:a="http://schemas.openxmlformats.org/drawingml/2006/main"/>
           <a:p xmlns:a="http://schemas.openxmlformats.org/drawingml/2006/main">
             <a:pPr algn="l">
+              <a:buNone/>
               <a:defRPr sz="3225" b="1">
                 <a:solidFill>
                   <a:srgbClr val="171717"/>
@@ -2014,6 +2022,7 @@
           <a:lstStyle xmlns:a="http://schemas.openxmlformats.org/drawingml/2006/main"/>
           <a:p xmlns:a="http://schemas.openxmlformats.org/drawingml/2006/main">
             <a:pPr algn="l">
+              <a:buNone/>
               <a:defRPr sz="1125" b="1">
                 <a:solidFill>
                   <a:srgbClr val="626262"/>
@@ -2064,6 +2073,7 @@
           <a:lstStyle xmlns:a="http://schemas.openxmlformats.org/drawingml/2006/main"/>
           <a:p xmlns:a="http://schemas.openxmlformats.org/drawingml/2006/main">
             <a:pPr algn="l">
+              <a:buNone/>
               <a:defRPr sz="2100" b="0">
                 <a:solidFill>
                   <a:srgbClr val="626262"/>
@@ -2145,6 +2155,7 @@
           <a:lstStyle xmlns:a="http://schemas.openxmlformats.org/drawingml/2006/main"/>
           <a:p xmlns:a="http://schemas.openxmlformats.org/drawingml/2006/main">
             <a:pPr algn="l">
+              <a:buNone/>
               <a:defRPr sz="1125" b="1">
                 <a:solidFill>
                   <a:srgbClr val="D52B1E"/>
@@ -2195,6 +2206,7 @@
           <a:lstStyle xmlns:a="http://schemas.openxmlformats.org/drawingml/2006/main"/>
           <a:p xmlns:a="http://schemas.openxmlformats.org/drawingml/2006/main">
             <a:pPr algn="l">
+              <a:buNone/>
               <a:defRPr sz="2700" b="1">
                 <a:solidFill>
                   <a:srgbClr val="171717"/>
@@ -2245,6 +2257,7 @@
           <a:lstStyle xmlns:a="http://schemas.openxmlformats.org/drawingml/2006/main"/>
           <a:p xmlns:a="http://schemas.openxmlformats.org/drawingml/2006/main">
             <a:pPr algn="l">
+              <a:buNone/>
               <a:defRPr sz="1500" b="1">
                 <a:solidFill>
                   <a:srgbClr val="D52B1E"/>
@@ -2324,6 +2337,7 @@
           <a:lstStyle xmlns:a="http://schemas.openxmlformats.org/drawingml/2006/main"/>
           <a:p xmlns:a="http://schemas.openxmlformats.org/drawingml/2006/main">
             <a:pPr algn="l">
+              <a:buNone/>
               <a:defRPr sz="1050" b="1">
                 <a:solidFill>
                   <a:srgbClr val="D52B1E"/>
@@ -2374,6 +2388,7 @@
           <a:lstStyle xmlns:a="http://schemas.openxmlformats.org/drawingml/2006/main"/>
           <a:p xmlns:a="http://schemas.openxmlformats.org/drawingml/2006/main">
             <a:pPr algn="l">
+              <a:buNone/>
               <a:defRPr sz="825" b="1">
                 <a:solidFill>
                   <a:srgbClr val="626262"/>
@@ -2424,6 +2439,7 @@
           <a:lstStyle xmlns:a="http://schemas.openxmlformats.org/drawingml/2006/main"/>
           <a:p xmlns:a="http://schemas.openxmlformats.org/drawingml/2006/main">
             <a:pPr algn="l">
+              <a:buNone/>
               <a:defRPr sz="3150" b="1">
                 <a:solidFill>
                   <a:srgbClr val="171717"/>
@@ -2474,6 +2490,7 @@
           <a:lstStyle xmlns:a="http://schemas.openxmlformats.org/drawingml/2006/main"/>
           <a:p xmlns:a="http://schemas.openxmlformats.org/drawingml/2006/main">
             <a:pPr algn="l">
+              <a:buNone/>
               <a:defRPr sz="1200" b="1">
                 <a:solidFill>
                   <a:srgbClr val="D52B1E"/>
@@ -2524,6 +2541,7 @@
           <a:lstStyle xmlns:a="http://schemas.openxmlformats.org/drawingml/2006/main"/>
           <a:p xmlns:a="http://schemas.openxmlformats.org/drawingml/2006/main">
             <a:pPr algn="l">
+              <a:buNone/>
               <a:defRPr sz="2100" b="1">
                 <a:solidFill>
                   <a:srgbClr val="171717"/>
@@ -2574,6 +2592,7 @@
           <a:lstStyle xmlns:a="http://schemas.openxmlformats.org/drawingml/2006/main"/>
           <a:p xmlns:a="http://schemas.openxmlformats.org/drawingml/2006/main">
             <a:pPr algn="l">
+              <a:buNone/>
               <a:defRPr sz="1500" b="0">
                 <a:solidFill>
                   <a:srgbClr val="626262"/>
@@ -2655,6 +2674,7 @@
           <a:lstStyle xmlns:a="http://schemas.openxmlformats.org/drawingml/2006/main"/>
           <a:p xmlns:a="http://schemas.openxmlformats.org/drawingml/2006/main">
             <a:pPr algn="l">
+              <a:buNone/>
               <a:defRPr sz="1200" b="1">
                 <a:solidFill>
                   <a:srgbClr val="D52B1E"/>
@@ -2705,6 +2725,7 @@
           <a:lstStyle xmlns:a="http://schemas.openxmlformats.org/drawingml/2006/main"/>
           <a:p xmlns:a="http://schemas.openxmlformats.org/drawingml/2006/main">
             <a:pPr algn="l">
+              <a:buNone/>
               <a:defRPr sz="2100" b="1">
                 <a:solidFill>
                   <a:srgbClr val="171717"/>
@@ -2755,6 +2776,7 @@
           <a:lstStyle xmlns:a="http://schemas.openxmlformats.org/drawingml/2006/main"/>
           <a:p xmlns:a="http://schemas.openxmlformats.org/drawingml/2006/main">
             <a:pPr algn="l">
+              <a:buNone/>
               <a:defRPr sz="1500" b="0">
                 <a:solidFill>
                   <a:srgbClr val="626262"/>
@@ -2836,6 +2858,7 @@
           <a:lstStyle xmlns:a="http://schemas.openxmlformats.org/drawingml/2006/main"/>
           <a:p xmlns:a="http://schemas.openxmlformats.org/drawingml/2006/main">
             <a:pPr algn="l">
+              <a:buNone/>
               <a:defRPr sz="1200" b="1">
                 <a:solidFill>
                   <a:srgbClr val="D52B1E"/>
@@ -2886,6 +2909,7 @@
           <a:lstStyle xmlns:a="http://schemas.openxmlformats.org/drawingml/2006/main"/>
           <a:p xmlns:a="http://schemas.openxmlformats.org/drawingml/2006/main">
             <a:pPr algn="l">
+              <a:buNone/>
               <a:defRPr sz="2100" b="1">
                 <a:solidFill>
                   <a:srgbClr val="171717"/>
@@ -2936,6 +2960,7 @@
           <a:lstStyle xmlns:a="http://schemas.openxmlformats.org/drawingml/2006/main"/>
           <a:p xmlns:a="http://schemas.openxmlformats.org/drawingml/2006/main">
             <a:pPr algn="l">
+              <a:buNone/>
               <a:defRPr sz="1500" b="0">
                 <a:solidFill>
                   <a:srgbClr val="626262"/>
@@ -3015,6 +3040,7 @@
           <a:lstStyle xmlns:a="http://schemas.openxmlformats.org/drawingml/2006/main"/>
           <a:p xmlns:a="http://schemas.openxmlformats.org/drawingml/2006/main">
             <a:pPr algn="l">
+              <a:buNone/>
               <a:defRPr sz="1050" b="1">
                 <a:solidFill>
                   <a:srgbClr val="D52B1E"/>
@@ -3065,6 +3091,7 @@
           <a:lstStyle xmlns:a="http://schemas.openxmlformats.org/drawingml/2006/main"/>
           <a:p xmlns:a="http://schemas.openxmlformats.org/drawingml/2006/main">
             <a:pPr algn="l">
+              <a:buNone/>
               <a:defRPr sz="825" b="1">
                 <a:solidFill>
                   <a:srgbClr val="626262"/>
@@ -3115,6 +3142,7 @@
           <a:lstStyle xmlns:a="http://schemas.openxmlformats.org/drawingml/2006/main"/>
           <a:p xmlns:a="http://schemas.openxmlformats.org/drawingml/2006/main">
             <a:pPr algn="l">
+              <a:buNone/>
               <a:defRPr sz="3150" b="1">
                 <a:solidFill>
                   <a:srgbClr val="171717"/>
@@ -3231,6 +3259,7 @@
           <a:lstStyle xmlns:a="http://schemas.openxmlformats.org/drawingml/2006/main"/>
           <a:p xmlns:a="http://schemas.openxmlformats.org/drawingml/2006/main">
             <a:pPr algn="l">
+              <a:buNone/>
               <a:defRPr sz="975" b="1">
                 <a:solidFill>
                   <a:srgbClr val="D52B1E"/>
@@ -3281,6 +3310,7 @@
           <a:lstStyle xmlns:a="http://schemas.openxmlformats.org/drawingml/2006/main"/>
           <a:p xmlns:a="http://schemas.openxmlformats.org/drawingml/2006/main">
             <a:pPr algn="l">
+              <a:buNone/>
               <a:defRPr sz="1350" b="1">
                 <a:solidFill>
                   <a:srgbClr val="171717"/>
@@ -3331,6 +3361,7 @@
           <a:lstStyle xmlns:a="http://schemas.openxmlformats.org/drawingml/2006/main"/>
           <a:p xmlns:a="http://schemas.openxmlformats.org/drawingml/2006/main">
             <a:pPr algn="l">
+              <a:buNone/>
               <a:defRPr sz="1125" b="0">
                 <a:solidFill>
                   <a:srgbClr val="626262"/>
@@ -3447,6 +3478,7 @@
           <a:lstStyle xmlns:a="http://schemas.openxmlformats.org/drawingml/2006/main"/>
           <a:p xmlns:a="http://schemas.openxmlformats.org/drawingml/2006/main">
             <a:pPr algn="l">
+              <a:buNone/>
               <a:defRPr sz="975" b="1">
                 <a:solidFill>
                   <a:srgbClr val="D52B1E"/>
@@ -3497,6 +3529,7 @@
           <a:lstStyle xmlns:a="http://schemas.openxmlformats.org/drawingml/2006/main"/>
           <a:p xmlns:a="http://schemas.openxmlformats.org/drawingml/2006/main">
             <a:pPr algn="l">
+              <a:buNone/>
               <a:defRPr sz="1350" b="1">
                 <a:solidFill>
                   <a:srgbClr val="171717"/>
@@ -3547,6 +3580,7 @@
           <a:lstStyle xmlns:a="http://schemas.openxmlformats.org/drawingml/2006/main"/>
           <a:p xmlns:a="http://schemas.openxmlformats.org/drawingml/2006/main">
             <a:pPr algn="l">
+              <a:buNone/>
               <a:defRPr sz="1125" b="0">
                 <a:solidFill>
                   <a:srgbClr val="626262"/>
@@ -3663,6 +3697,7 @@
           <a:lstStyle xmlns:a="http://schemas.openxmlformats.org/drawingml/2006/main"/>
           <a:p xmlns:a="http://schemas.openxmlformats.org/drawingml/2006/main">
             <a:pPr algn="l">
+              <a:buNone/>
               <a:defRPr sz="975" b="1">
                 <a:solidFill>
                   <a:srgbClr val="D52B1E"/>
@@ -3713,6 +3748,7 @@
           <a:lstStyle xmlns:a="http://schemas.openxmlformats.org/drawingml/2006/main"/>
           <a:p xmlns:a="http://schemas.openxmlformats.org/drawingml/2006/main">
             <a:pPr algn="l">
+              <a:buNone/>
               <a:defRPr sz="1350" b="1">
                 <a:solidFill>
                   <a:srgbClr val="171717"/>
@@ -3763,6 +3799,7 @@
           <a:lstStyle xmlns:a="http://schemas.openxmlformats.org/drawingml/2006/main"/>
           <a:p xmlns:a="http://schemas.openxmlformats.org/drawingml/2006/main">
             <a:pPr algn="l">
+              <a:buNone/>
               <a:defRPr sz="1125" b="0">
                 <a:solidFill>
                   <a:srgbClr val="626262"/>
@@ -3879,6 +3916,7 @@
           <a:lstStyle xmlns:a="http://schemas.openxmlformats.org/drawingml/2006/main"/>
           <a:p xmlns:a="http://schemas.openxmlformats.org/drawingml/2006/main">
             <a:pPr algn="l">
+              <a:buNone/>
               <a:defRPr sz="975" b="1">
                 <a:solidFill>
                   <a:srgbClr val="D52B1E"/>
@@ -3929,6 +3967,7 @@
           <a:lstStyle xmlns:a="http://schemas.openxmlformats.org/drawingml/2006/main"/>
           <a:p xmlns:a="http://schemas.openxmlformats.org/drawingml/2006/main">
             <a:pPr algn="l">
+              <a:buNone/>
               <a:defRPr sz="1350" b="1">
                 <a:solidFill>
                   <a:srgbClr val="171717"/>
@@ -3979,6 +4018,7 @@
           <a:lstStyle xmlns:a="http://schemas.openxmlformats.org/drawingml/2006/main"/>
           <a:p xmlns:a="http://schemas.openxmlformats.org/drawingml/2006/main">
             <a:pPr algn="l">
+              <a:buNone/>
               <a:defRPr sz="1125" b="0">
                 <a:solidFill>
                   <a:srgbClr val="626262"/>
@@ -4064,6 +4104,7 @@
           <a:lstStyle xmlns:a="http://schemas.openxmlformats.org/drawingml/2006/main"/>
           <a:p xmlns:a="http://schemas.openxmlformats.org/drawingml/2006/main">
             <a:pPr algn="l">
+              <a:buNone/>
               <a:defRPr sz="975" b="1">
                 <a:solidFill>
                   <a:srgbClr val="FFFFFF"/>
@@ -4114,6 +4155,7 @@
           <a:lstStyle xmlns:a="http://schemas.openxmlformats.org/drawingml/2006/main"/>
           <a:p xmlns:a="http://schemas.openxmlformats.org/drawingml/2006/main">
             <a:pPr algn="l">
+              <a:buNone/>
               <a:defRPr sz="1350" b="1">
                 <a:solidFill>
                   <a:srgbClr val="FFFFFF"/>
@@ -4164,6 +4206,7 @@
           <a:lstStyle xmlns:a="http://schemas.openxmlformats.org/drawingml/2006/main"/>
           <a:p xmlns:a="http://schemas.openxmlformats.org/drawingml/2006/main">
             <a:pPr algn="l">
+              <a:buNone/>
               <a:defRPr sz="1125" b="0">
                 <a:solidFill>
                   <a:srgbClr val="FFFFFF"/>
@@ -4214,6 +4257,7 @@
           <a:lstStyle xmlns:a="http://schemas.openxmlformats.org/drawingml/2006/main"/>
           <a:p xmlns:a="http://schemas.openxmlformats.org/drawingml/2006/main">
             <a:pPr algn="l">
+              <a:buNone/>
               <a:defRPr sz="1725" b="1">
                 <a:solidFill>
                   <a:srgbClr val="171717"/>
@@ -4293,6 +4337,7 @@
           <a:lstStyle xmlns:a="http://schemas.openxmlformats.org/drawingml/2006/main"/>
           <a:p xmlns:a="http://schemas.openxmlformats.org/drawingml/2006/main">
             <a:pPr algn="l">
+              <a:buNone/>
               <a:defRPr sz="1050" b="1">
                 <a:solidFill>
                   <a:srgbClr val="D52B1E"/>
@@ -4305,7 +4350,7 @@
                   <a:srgbClr val="D52B1E"/>
                 </a:solidFill>
               </a:rPr>
-              <a:t>OPERATIONAL INTELLIGENCE</a:t>
+              <a:t>REPORTING ASSISTANT</a:t>
             </a:r>
           </a:p>
         </p:txBody>
@@ -4343,6 +4388,7 @@
           <a:lstStyle xmlns:a="http://schemas.openxmlformats.org/drawingml/2006/main"/>
           <a:p xmlns:a="http://schemas.openxmlformats.org/drawingml/2006/main">
             <a:pPr algn="l">
+              <a:buNone/>
               <a:defRPr sz="825" b="1">
                 <a:solidFill>
                   <a:srgbClr val="626262"/>
@@ -4393,6 +4439,7 @@
           <a:lstStyle xmlns:a="http://schemas.openxmlformats.org/drawingml/2006/main"/>
           <a:p xmlns:a="http://schemas.openxmlformats.org/drawingml/2006/main">
             <a:pPr algn="l">
+              <a:buNone/>
               <a:defRPr sz="3000" b="1">
                 <a:solidFill>
                   <a:srgbClr val="171717"/>
@@ -4405,7 +4452,7 @@
                   <a:srgbClr val="171717"/>
                 </a:solidFill>
               </a:rPr>
-              <a:t>Retrieve, diagnose, and validate - without taking authority.</a:t>
+              <a:t>One assistant. Three controlled capabilities.</a:t>
             </a:r>
           </a:p>
         </p:txBody>
@@ -4443,6 +4490,7 @@
           <a:lstStyle xmlns:a="http://schemas.openxmlformats.org/drawingml/2006/main"/>
           <a:p xmlns:a="http://schemas.openxmlformats.org/drawingml/2006/main">
             <a:pPr algn="l">
+              <a:buNone/>
               <a:defRPr sz="1125" b="1">
                 <a:solidFill>
                   <a:srgbClr val="D52B1E"/>
@@ -4493,6 +4541,7 @@
           <a:lstStyle xmlns:a="http://schemas.openxmlformats.org/drawingml/2006/main"/>
           <a:p xmlns:a="http://schemas.openxmlformats.org/drawingml/2006/main">
             <a:pPr algn="l">
+              <a:buNone/>
               <a:defRPr sz="1800" b="1">
                 <a:solidFill>
                   <a:srgbClr val="171717"/>
@@ -4505,11 +4554,12 @@
                   <a:srgbClr val="171717"/>
                 </a:solidFill>
               </a:rPr>
-              <a:t>Bounded chatbot</a:t>
-            </a:r>
-          </a:p>
-          <a:p xmlns:a="http://schemas.openxmlformats.org/drawingml/2006/main">
-            <a:pPr algn="l">
+              <a:t>Find cited information</a:t>
+            </a:r>
+          </a:p>
+          <a:p xmlns:a="http://schemas.openxmlformats.org/drawingml/2006/main">
+            <a:pPr algn="l">
+              <a:buNone/>
               <a:defRPr sz="1800" b="1">
                 <a:solidFill>
                   <a:srgbClr val="171717"/>
@@ -4522,7 +4572,7 @@
                   <a:srgbClr val="171717"/>
                 </a:solidFill>
               </a:rPr>
-              <a:t>Citations + fallback</a:t>
+              <a:t>Governed sources + fallback</a:t>
             </a:r>
           </a:p>
         </p:txBody>
@@ -4560,6 +4610,7 @@
           <a:lstStyle xmlns:a="http://schemas.openxmlformats.org/drawingml/2006/main"/>
           <a:p xmlns:a="http://schemas.openxmlformats.org/drawingml/2006/main">
             <a:pPr algn="l">
+              <a:buNone/>
               <a:defRPr sz="1125" b="1">
                 <a:solidFill>
                   <a:srgbClr val="D52B1E"/>
@@ -4610,6 +4661,7 @@
           <a:lstStyle xmlns:a="http://schemas.openxmlformats.org/drawingml/2006/main"/>
           <a:p xmlns:a="http://schemas.openxmlformats.org/drawingml/2006/main">
             <a:pPr algn="l">
+              <a:buNone/>
               <a:defRPr sz="1800" b="1">
                 <a:solidFill>
                   <a:srgbClr val="171717"/>
@@ -4622,11 +4674,12 @@
                   <a:srgbClr val="171717"/>
                 </a:solidFill>
               </a:rPr>
-              <a:t>Read-only doctor</a:t>
-            </a:r>
-          </a:p>
-          <a:p xmlns:a="http://schemas.openxmlformats.org/drawingml/2006/main">
-            <a:pPr algn="l">
+              <a:t>Diagnose report problems</a:t>
+            </a:r>
+          </a:p>
+          <a:p xmlns:a="http://schemas.openxmlformats.org/drawingml/2006/main">
+            <a:pPr algn="l">
+              <a:buNone/>
               <a:defRPr sz="1800" b="1">
                 <a:solidFill>
                   <a:srgbClr val="171717"/>
@@ -4677,6 +4730,7 @@
           <a:lstStyle xmlns:a="http://schemas.openxmlformats.org/drawingml/2006/main"/>
           <a:p xmlns:a="http://schemas.openxmlformats.org/drawingml/2006/main">
             <a:pPr algn="l">
+              <a:buNone/>
               <a:defRPr sz="1125" b="1">
                 <a:solidFill>
                   <a:srgbClr val="D52B1E"/>
@@ -4727,6 +4781,7 @@
           <a:lstStyle xmlns:a="http://schemas.openxmlformats.org/drawingml/2006/main"/>
           <a:p xmlns:a="http://schemas.openxmlformats.org/drawingml/2006/main">
             <a:pPr algn="l">
+              <a:buNone/>
               <a:defRPr sz="1800" b="1">
                 <a:solidFill>
                   <a:srgbClr val="171717"/>
@@ -4739,11 +4794,12 @@
                   <a:srgbClr val="171717"/>
                 </a:solidFill>
               </a:rPr>
-              <a:t>Governed oracle</a:t>
-            </a:r>
-          </a:p>
-          <a:p xmlns:a="http://schemas.openxmlformats.org/drawingml/2006/main">
-            <a:pPr algn="l">
+              <a:t>Validate evidence</a:t>
+            </a:r>
+          </a:p>
+          <a:p xmlns:a="http://schemas.openxmlformats.org/drawingml/2006/main">
+            <a:pPr algn="l">
+              <a:buNone/>
               <a:defRPr sz="1800" b="1">
                 <a:solidFill>
                   <a:srgbClr val="171717"/>
@@ -4825,6 +4881,7 @@
           <a:lstStyle xmlns:a="http://schemas.openxmlformats.org/drawingml/2006/main"/>
           <a:p xmlns:a="http://schemas.openxmlformats.org/drawingml/2006/main">
             <a:pPr algn="ctr">
+              <a:buNone/>
               <a:defRPr sz="1875" b="1">
                 <a:solidFill>
                   <a:srgbClr val="171717"/>
@@ -4904,6 +4961,7 @@
           <a:lstStyle xmlns:a="http://schemas.openxmlformats.org/drawingml/2006/main"/>
           <a:p xmlns:a="http://schemas.openxmlformats.org/drawingml/2006/main">
             <a:pPr algn="l">
+              <a:buNone/>
               <a:defRPr sz="1050" b="1">
                 <a:solidFill>
                   <a:srgbClr val="D52B1E"/>
@@ -4954,6 +5012,7 @@
           <a:lstStyle xmlns:a="http://schemas.openxmlformats.org/drawingml/2006/main"/>
           <a:p xmlns:a="http://schemas.openxmlformats.org/drawingml/2006/main">
             <a:pPr algn="l">
+              <a:buNone/>
               <a:defRPr sz="825" b="1">
                 <a:solidFill>
                   <a:srgbClr val="626262"/>
@@ -5004,6 +5063,7 @@
           <a:lstStyle xmlns:a="http://schemas.openxmlformats.org/drawingml/2006/main"/>
           <a:p xmlns:a="http://schemas.openxmlformats.org/drawingml/2006/main">
             <a:pPr algn="l">
+              <a:buNone/>
               <a:defRPr sz="3150" b="1">
                 <a:solidFill>
                   <a:srgbClr val="171717"/>
@@ -5054,6 +5114,7 @@
           <a:lstStyle xmlns:a="http://schemas.openxmlformats.org/drawingml/2006/main"/>
           <a:p xmlns:a="http://schemas.openxmlformats.org/drawingml/2006/main">
             <a:pPr algn="l">
+              <a:buNone/>
               <a:defRPr sz="5400" b="1">
                 <a:solidFill>
                   <a:srgbClr val="D52B1E"/>
@@ -5104,6 +5165,7 @@
           <a:lstStyle xmlns:a="http://schemas.openxmlformats.org/drawingml/2006/main"/>
           <a:p xmlns:a="http://schemas.openxmlformats.org/drawingml/2006/main">
             <a:pPr algn="l">
+              <a:buNone/>
               <a:defRPr sz="1650" b="1">
                 <a:solidFill>
                   <a:srgbClr val="171717"/>
@@ -5154,6 +5216,7 @@
           <a:lstStyle xmlns:a="http://schemas.openxmlformats.org/drawingml/2006/main"/>
           <a:p xmlns:a="http://schemas.openxmlformats.org/drawingml/2006/main">
             <a:pPr algn="l">
+              <a:buNone/>
               <a:defRPr sz="1350" b="0">
                 <a:solidFill>
                   <a:srgbClr val="626262"/>
@@ -5171,6 +5234,7 @@
           </a:p>
           <a:p xmlns:a="http://schemas.openxmlformats.org/drawingml/2006/main">
             <a:pPr algn="l">
+              <a:buNone/>
               <a:defRPr sz="1350" b="0">
                 <a:solidFill>
                   <a:srgbClr val="626262"/>
@@ -5221,6 +5285,7 @@
           <a:lstStyle xmlns:a="http://schemas.openxmlformats.org/drawingml/2006/main"/>
           <a:p xmlns:a="http://schemas.openxmlformats.org/drawingml/2006/main">
             <a:pPr algn="l">
+              <a:buNone/>
               <a:defRPr sz="4950" b="1">
                 <a:solidFill>
                   <a:srgbClr val="D52B1E"/>
@@ -5271,6 +5336,7 @@
           <a:lstStyle xmlns:a="http://schemas.openxmlformats.org/drawingml/2006/main"/>
           <a:p xmlns:a="http://schemas.openxmlformats.org/drawingml/2006/main">
             <a:pPr algn="l">
+              <a:buNone/>
               <a:defRPr sz="1350" b="0">
                 <a:solidFill>
                   <a:srgbClr val="626262"/>
@@ -5288,6 +5354,7 @@
           </a:p>
           <a:p xmlns:a="http://schemas.openxmlformats.org/drawingml/2006/main">
             <a:pPr algn="l">
+              <a:buNone/>
               <a:defRPr sz="1350" b="0">
                 <a:solidFill>
                   <a:srgbClr val="626262"/>
@@ -5338,6 +5405,7 @@
           <a:lstStyle xmlns:a="http://schemas.openxmlformats.org/drawingml/2006/main"/>
           <a:p xmlns:a="http://schemas.openxmlformats.org/drawingml/2006/main">
             <a:pPr algn="l">
+              <a:buNone/>
               <a:defRPr sz="1050" b="1">
                 <a:solidFill>
                   <a:srgbClr val="D52B1E"/>
@@ -5388,6 +5456,7 @@
           <a:lstStyle xmlns:a="http://schemas.openxmlformats.org/drawingml/2006/main"/>
           <a:p xmlns:a="http://schemas.openxmlformats.org/drawingml/2006/main">
             <a:pPr algn="l">
+              <a:buNone/>
               <a:defRPr sz="1875" b="1">
                 <a:solidFill>
                   <a:srgbClr val="171717"/>
@@ -5405,6 +5474,7 @@
           </a:p>
           <a:p xmlns:a="http://schemas.openxmlformats.org/drawingml/2006/main">
             <a:pPr algn="l">
+              <a:buNone/>
               <a:defRPr sz="1875" b="1">
                 <a:solidFill>
                   <a:srgbClr val="171717"/>
@@ -5490,6 +5560,7 @@
           <a:lstStyle xmlns:a="http://schemas.openxmlformats.org/drawingml/2006/main"/>
           <a:p xmlns:a="http://schemas.openxmlformats.org/drawingml/2006/main">
             <a:pPr algn="ctr">
+              <a:buNone/>
               <a:defRPr sz="1500" b="1">
                 <a:solidFill>
                   <a:srgbClr val="171717"/>
@@ -5569,6 +5640,7 @@
           <a:lstStyle xmlns:a="http://schemas.openxmlformats.org/drawingml/2006/main"/>
           <a:p xmlns:a="http://schemas.openxmlformats.org/drawingml/2006/main">
             <a:pPr algn="l">
+              <a:buNone/>
               <a:defRPr sz="1050" b="1">
                 <a:solidFill>
                   <a:srgbClr val="FF665C"/>
@@ -5619,6 +5691,7 @@
           <a:lstStyle xmlns:a="http://schemas.openxmlformats.org/drawingml/2006/main"/>
           <a:p xmlns:a="http://schemas.openxmlformats.org/drawingml/2006/main">
             <a:pPr algn="l">
+              <a:buNone/>
               <a:defRPr sz="3750" b="1">
                 <a:solidFill>
                   <a:srgbClr val="FFFFFF"/>
@@ -5669,6 +5742,7 @@
           <a:lstStyle xmlns:a="http://schemas.openxmlformats.org/drawingml/2006/main"/>
           <a:p xmlns:a="http://schemas.openxmlformats.org/drawingml/2006/main">
             <a:pPr algn="l">
+              <a:buNone/>
               <a:defRPr sz="1875" b="0">
                 <a:solidFill>
                   <a:srgbClr val="C6C6C6"/>
@@ -5686,6 +5760,7 @@
           </a:p>
           <a:p xmlns:a="http://schemas.openxmlformats.org/drawingml/2006/main">
             <a:pPr algn="l">
+              <a:buNone/>
               <a:defRPr sz="1875" b="0">
                 <a:solidFill>
                   <a:srgbClr val="C6C6C6"/>
@@ -5767,6 +5842,7 @@
           <a:lstStyle xmlns:a="http://schemas.openxmlformats.org/drawingml/2006/main"/>
           <a:p xmlns:a="http://schemas.openxmlformats.org/drawingml/2006/main">
             <a:pPr algn="l">
+              <a:buNone/>
               <a:defRPr sz="1425" b="1">
                 <a:solidFill>
                   <a:srgbClr val="FFFFFF"/>

</xml_diff>

<commit_message>
Align public case study and delivered assistant status
</commit_message>
<xml_diff>
--- a/public/Thomas-Ryan-PepperBall-Platform-Case-Study.pptx
+++ b/public/Thomas-Ryan-PepperBall-Platform-Case-Study.pptx
@@ -2,20 +2,20 @@
 <file path=ppt/presentation.xml><?xml version="1.0" encoding="utf-8"?>
 <p:presentation xmlns:p="http://schemas.openxmlformats.org/presentationml/2006/main">
   <p:sldMasterIdLst>
-    <p:sldMasterId xmlns:r="http://schemas.openxmlformats.org/officeDocument/2006/relationships" id="2147483648" r:id="Rcb8898ddd915416a"/>
+    <p:sldMasterId xmlns:r="http://schemas.openxmlformats.org/officeDocument/2006/relationships" id="2147483648" r:id="Rad6e5ebb66f94253"/>
   </p:sldMasterIdLst>
   <p:notesMasterIdLst>
-    <p:notesMasterId xmlns:r="http://schemas.openxmlformats.org/officeDocument/2006/relationships" r:id="R17102fb0c9744a6e"/>
+    <p:notesMasterId xmlns:r="http://schemas.openxmlformats.org/officeDocument/2006/relationships" r:id="Re478cfb7f0e54ca5"/>
   </p:notesMasterIdLst>
   <p:sldIdLst>
-    <p:sldId xmlns:r="http://schemas.openxmlformats.org/officeDocument/2006/relationships" id="256" r:id="R381b1b612b704840"/>
-    <p:sldId xmlns:r="http://schemas.openxmlformats.org/officeDocument/2006/relationships" id="257" r:id="R9283f6f836ce4155"/>
-    <p:sldId xmlns:r="http://schemas.openxmlformats.org/officeDocument/2006/relationships" id="258" r:id="R220e8760c56b4741"/>
-    <p:sldId xmlns:r="http://schemas.openxmlformats.org/officeDocument/2006/relationships" id="259" r:id="R341672a5a99f43db"/>
-    <p:sldId xmlns:r="http://schemas.openxmlformats.org/officeDocument/2006/relationships" id="260" r:id="R192cf825ecf94122"/>
-    <p:sldId xmlns:r="http://schemas.openxmlformats.org/officeDocument/2006/relationships" id="261" r:id="R9bd2463e2acc43d7"/>
-    <p:sldId xmlns:r="http://schemas.openxmlformats.org/officeDocument/2006/relationships" id="262" r:id="R3783f2c4dfd84d5a"/>
-    <p:sldId xmlns:r="http://schemas.openxmlformats.org/officeDocument/2006/relationships" id="263" r:id="R6148c34f2d6b4d91"/>
+    <p:sldId xmlns:r="http://schemas.openxmlformats.org/officeDocument/2006/relationships" id="256" r:id="Rf0a588de4cd649b1"/>
+    <p:sldId xmlns:r="http://schemas.openxmlformats.org/officeDocument/2006/relationships" id="257" r:id="Rb1e6c9ef35ac4534"/>
+    <p:sldId xmlns:r="http://schemas.openxmlformats.org/officeDocument/2006/relationships" id="258" r:id="Rd6a8ed493b0a4cd6"/>
+    <p:sldId xmlns:r="http://schemas.openxmlformats.org/officeDocument/2006/relationships" id="259" r:id="R9a4d3cea54e04c87"/>
+    <p:sldId xmlns:r="http://schemas.openxmlformats.org/officeDocument/2006/relationships" id="260" r:id="Ra5d2b1f247904452"/>
+    <p:sldId xmlns:r="http://schemas.openxmlformats.org/officeDocument/2006/relationships" id="261" r:id="Rd3b88cc976f14e77"/>
+    <p:sldId xmlns:r="http://schemas.openxmlformats.org/officeDocument/2006/relationships" id="262" r:id="R2b375dbb2bfd466a"/>
+    <p:sldId xmlns:r="http://schemas.openxmlformats.org/officeDocument/2006/relationships" id="263" r:id="Re1f8543c0ab64b4d"/>
   </p:sldIdLst>
   <p:sldSz cx="12192000" cy="6858000"/>
   <p:notesSz cx="6858000" cy="9144000"/>
@@ -449,7 +449,7 @@
           <a:lstStyle xmlns:a="http://schemas.openxmlformats.org/drawingml/2006/main"/>
           <a:p xmlns:a="http://schemas.openxmlformats.org/drawingml/2006/main">
             <a:r>
-              <a:t>Open with the system outcome, then name the operating context. The core claim is reliability across the full source-to-user path, not a standalone spreadsheet generator.</a:t>
+              <a:t>Open with the delivered scope: Shift Drafts and daily, weekly, and downtime reporting are the core platform. Machine-event visibility and a functional read-only Reporting Assistant are delivered extensions. Broader model-backed reasoning, document knowledge, recurring artifacts, and production advisory remain future work.</a:t>
             </a:r>
           </a:p>
           <a:p xmlns:a="http://schemas.openxmlformats.org/drawingml/2006/main">
@@ -470,6 +470,11 @@
           <a:p xmlns:a="http://schemas.openxmlformats.org/drawingml/2006/main">
             <a:r>
               <a:t>- docs/case-study.md</a:t>
+            </a:r>
+          </a:p>
+          <a:p xmlns:a="http://schemas.openxmlformats.org/drawingml/2006/main">
+            <a:r>
+              <a:t>- docs/claim-boundaries.md</a:t>
             </a:r>
           </a:p>
           <a:p xmlns:a="http://schemas.openxmlformats.org/drawingml/2006/main">
@@ -639,7 +644,7 @@
           <a:lstStyle xmlns:a="http://schemas.openxmlformats.org/drawingml/2006/main"/>
           <a:p xmlns:a="http://schemas.openxmlformats.org/drawingml/2006/main">
             <a:r>
-              <a:t>Walk clockwise. Original evidence stays authoritative, user surfaces stay read-only, repair reuses the canonical path, and release controls govern the same writer boundary.</a:t>
+              <a:t>Walk clockwise. Original evidence stays authoritative, report, machine-status, and assistant surfaces remain read-only, repair reuses the canonical path, and release controls govern the same writer boundary. The functional assistant reuses governed contracts without creating publication authority.</a:t>
             </a:r>
           </a:p>
           <a:p xmlns:a="http://schemas.openxmlformats.org/drawingml/2006/main">
@@ -660,6 +665,11 @@
           <a:p xmlns:a="http://schemas.openxmlformats.org/drawingml/2006/main">
             <a:r>
               <a:t>- docs/architecture.md</a:t>
+            </a:r>
+          </a:p>
+          <a:p xmlns:a="http://schemas.openxmlformats.org/drawingml/2006/main">
+            <a:r>
+              <a:t>- docs/claim-boundaries.md</a:t>
             </a:r>
           </a:p>
           <a:p xmlns:a="http://schemas.openxmlformats.org/drawingml/2006/main">
@@ -1024,7 +1034,7 @@
           <a:lstStyle xmlns:a="http://schemas.openxmlformats.org/drawingml/2006/main"/>
           <a:p xmlns:a="http://schemas.openxmlformats.org/drawingml/2006/main">
             <a:r>
-              <a:t>The conformance result is limited to the reviewed sample: about one in four legacy reports failed the required production-count schema, while every reviewed system-generated output conformed. The remaining numbers are architecture and protocol invariants.</a:t>
+              <a:t>The four delivered report families are Shift Drafts, Daily Production, Weekly Production, and Weekly Downtime. The other numbers are architecture and protocol invariants: one active writer and zero retry PUTs after ambiguous accepted writes.</a:t>
             </a:r>
           </a:p>
           <a:p xmlns:a="http://schemas.openxmlformats.org/drawingml/2006/main">
@@ -1039,7 +1049,7 @@
           </a:p>
           <a:p xmlns:a="http://schemas.openxmlformats.org/drawingml/2006/main">
             <a:r>
-              <a:t>- docs/case-study.md</a:t>
+              <a:t>- docs/operational-use-and-impact.md</a:t>
             </a:r>
           </a:p>
           <a:p xmlns:a="http://schemas.openxmlformats.org/drawingml/2006/main">
@@ -1124,7 +1134,7 @@
           <a:lstStyle xmlns:a="http://schemas.openxmlformats.org/drawingml/2006/main"/>
           <a:p xmlns:a="http://schemas.openxmlformats.org/drawingml/2006/main">
             <a:r>
-              <a:t>Close on the engineering principle: reliable automation is defined as much by refusal and evidence as by successful mutation. Invite discussion at the system, reliability, or operational level.</a:t>
+              <a:t>Close on the engineering principle: reliable automation is defined as much by refusal and evidence as by successful mutation. The functional Reporting Assistant already inherits identity, lineage, access, citation, and refusal boundaries; broader model-backed reasoning and advisory capability remain future work.</a:t>
             </a:r>
           </a:p>
           <a:p xmlns:a="http://schemas.openxmlformats.org/drawingml/2006/main">
@@ -1145,6 +1155,11 @@
           <a:p xmlns:a="http://schemas.openxmlformats.org/drawingml/2006/main">
             <a:r>
               <a:t>- docs/interview-kit.md</a:t>
+            </a:r>
+          </a:p>
+          <a:p xmlns:a="http://schemas.openxmlformats.org/drawingml/2006/main">
+            <a:r>
+              <a:t>- docs/claim-boundaries.md</a:t>
             </a:r>
           </a:p>
           <a:p xmlns:a="http://schemas.openxmlformats.org/drawingml/2006/main">
@@ -1222,7 +1237,7 @@
   </p:cSld>
   <p:clrMap bg1="lt1" tx1="dk1" bg2="lt2" tx2="dk2" accent1="accent1" accent2="accent2" accent3="accent3" accent4="accent4" accent5="accent5" accent6="accent6" hlink="hlink" folHlink="folHlink"/>
   <p:sldLayoutIdLst>
-    <p:sldLayoutId xmlns:r="http://schemas.openxmlformats.org/officeDocument/2006/relationships" id="2147483649" r:id="Rb96d833a35094087"/>
+    <p:sldLayoutId xmlns:r="http://schemas.openxmlformats.org/officeDocument/2006/relationships" id="2147483649" r:id="Ra600d3afa4e24879"/>
   </p:sldLayoutIdLst>
   <p:txStyles>
     <p:titleStyle>
@@ -1803,6 +1818,7 @@
           <a:lstStyle xmlns:a="http://schemas.openxmlformats.org/drawingml/2006/main"/>
           <a:p xmlns:a="http://schemas.openxmlformats.org/drawingml/2006/main">
             <a:pPr algn="l">
+              <a:buNone/>
               <a:defRPr sz="1200" b="1">
                 <a:solidFill>
                   <a:srgbClr val="D52B1E"/>
@@ -1861,6 +1877,7 @@
           <a:lstStyle xmlns:a="http://schemas.openxmlformats.org/drawingml/2006/main"/>
           <a:p xmlns:a="http://schemas.openxmlformats.org/drawingml/2006/main">
             <a:pPr algn="l">
+              <a:buNone/>
               <a:defRPr sz="5550" b="1">
                 <a:solidFill>
                   <a:srgbClr val="171717"/>
@@ -1879,7 +1896,7 @@
                 <a:ea typeface="Aptos"/>
                 <a:cs typeface="Aptos"/>
               </a:rPr>
-              <a:t>A reporting platform that can explain and repair itself.</a:t>
+              <a:t>Manufacturing reporting that can explain and repair itself.</a:t>
             </a:r>
           </a:p>
         </p:txBody>
@@ -1914,11 +1931,12 @@
         </p:spPr>
         <p:txBody>
           <a:bodyPr xmlns:a="http://schemas.openxmlformats.org/drawingml/2006/main" wrap="square" lIns="0" tIns="0" rIns="0" bIns="0" anchor="t">
-            <a:normAutofit fontScale="100000"/>
-          </a:bodyPr>
-          <a:lstStyle xmlns:a="http://schemas.openxmlformats.org/drawingml/2006/main"/>
-          <a:p xmlns:a="http://schemas.openxmlformats.org/drawingml/2006/main">
-            <a:pPr algn="l">
+            <a:normAutofit fontScale="97222"/>
+          </a:bodyPr>
+          <a:lstStyle xmlns:a="http://schemas.openxmlformats.org/drawingml/2006/main"/>
+          <a:p xmlns:a="http://schemas.openxmlformats.org/drawingml/2006/main">
+            <a:pPr algn="l">
+              <a:buNone/>
               <a:defRPr sz="2100" b="0">
                 <a:solidFill>
                   <a:srgbClr val="626262"/>
@@ -1937,7 +1955,7 @@
                 <a:ea typeface="Aptos"/>
                 <a:cs typeface="Aptos"/>
               </a:rPr>
-              <a:t>From changing documents to governed facts, deterministic products, bounded recovery, and one-writer delivery.</a:t>
+              <a:t>Delivered reporting core, machine visibility and functional read-only Reporting Assistant extensions, with governed future expansion.</a:t>
             </a:r>
           </a:p>
         </p:txBody>
@@ -2012,6 +2030,7 @@
           <a:lstStyle xmlns:a="http://schemas.openxmlformats.org/drawingml/2006/main"/>
           <a:p xmlns:a="http://schemas.openxmlformats.org/drawingml/2006/main">
             <a:pPr algn="l">
+              <a:buNone/>
               <a:defRPr sz="1200" b="1">
                 <a:solidFill>
                   <a:srgbClr val="FFFFFF"/>
@@ -2070,6 +2089,7 @@
           <a:lstStyle xmlns:a="http://schemas.openxmlformats.org/drawingml/2006/main"/>
           <a:p xmlns:a="http://schemas.openxmlformats.org/drawingml/2006/main">
             <a:pPr algn="l">
+              <a:buNone/>
               <a:defRPr sz="1275" b="0">
                 <a:solidFill>
                   <a:srgbClr val="FFFFFF"/>
@@ -2093,6 +2113,7 @@
           </a:p>
           <a:p xmlns:a="http://schemas.openxmlformats.org/drawingml/2006/main">
             <a:pPr algn="l">
+              <a:buNone/>
               <a:defRPr sz="1275" b="0">
                 <a:solidFill>
                   <a:srgbClr val="FFFFFF"/>
@@ -2180,6 +2201,7 @@
           <a:lstStyle xmlns:a="http://schemas.openxmlformats.org/drawingml/2006/main"/>
           <a:p xmlns:a="http://schemas.openxmlformats.org/drawingml/2006/main">
             <a:pPr algn="l">
+              <a:buNone/>
               <a:defRPr sz="1200" b="1">
                 <a:solidFill>
                   <a:srgbClr val="D52B1E"/>
@@ -2238,6 +2260,7 @@
           <a:lstStyle xmlns:a="http://schemas.openxmlformats.org/drawingml/2006/main"/>
           <a:p xmlns:a="http://schemas.openxmlformats.org/drawingml/2006/main">
             <a:pPr algn="l">
+              <a:buNone/>
               <a:defRPr sz="3300" b="1">
                 <a:solidFill>
                   <a:srgbClr val="171717"/>
@@ -2296,6 +2319,7 @@
           <a:lstStyle xmlns:a="http://schemas.openxmlformats.org/drawingml/2006/main"/>
           <a:p xmlns:a="http://schemas.openxmlformats.org/drawingml/2006/main">
             <a:pPr algn="l">
+              <a:buNone/>
               <a:defRPr sz="1500" b="0">
                 <a:solidFill>
                   <a:srgbClr val="626262"/>
@@ -2321,7 +2345,7 @@
       </p:sp>
       <p:cxnSp>
         <p:nvCxnSpPr>
-          <p:cNvPr id="26" name=""/>
+          <p:cNvPr id="34" name=""/>
           <p:cNvCxnSpPr/>
           <p:nvPr/>
         </p:nvCxnSpPr>
@@ -2376,6 +2400,7 @@
           <a:lstStyle xmlns:a="http://schemas.openxmlformats.org/drawingml/2006/main"/>
           <a:p xmlns:a="http://schemas.openxmlformats.org/drawingml/2006/main">
             <a:pPr algn="l">
+              <a:buNone/>
               <a:defRPr sz="900" b="1">
                 <a:solidFill>
                   <a:srgbClr val="D52B1E"/>
@@ -2434,6 +2459,7 @@
           <a:lstStyle xmlns:a="http://schemas.openxmlformats.org/drawingml/2006/main"/>
           <a:p xmlns:a="http://schemas.openxmlformats.org/drawingml/2006/main">
             <a:pPr algn="r">
+              <a:buNone/>
               <a:defRPr sz="900" b="0">
                 <a:solidFill>
                   <a:srgbClr val="626262"/>
@@ -2527,6 +2553,7 @@
           <a:lstStyle xmlns:a="http://schemas.openxmlformats.org/drawingml/2006/main"/>
           <a:p xmlns:a="http://schemas.openxmlformats.org/drawingml/2006/main">
             <a:pPr algn="l">
+              <a:buNone/>
               <a:defRPr sz="975" b="1">
                 <a:solidFill>
                   <a:srgbClr val="D52B1E"/>
@@ -2585,6 +2612,7 @@
           <a:lstStyle xmlns:a="http://schemas.openxmlformats.org/drawingml/2006/main"/>
           <a:p xmlns:a="http://schemas.openxmlformats.org/drawingml/2006/main">
             <a:pPr algn="l">
+              <a:buNone/>
               <a:defRPr sz="1800" b="1">
                 <a:solidFill>
                   <a:srgbClr val="171717"/>
@@ -2643,6 +2671,7 @@
           <a:lstStyle xmlns:a="http://schemas.openxmlformats.org/drawingml/2006/main"/>
           <a:p xmlns:a="http://schemas.openxmlformats.org/drawingml/2006/main">
             <a:pPr algn="l">
+              <a:buNone/>
               <a:defRPr sz="1275" b="0">
                 <a:solidFill>
                   <a:srgbClr val="626262"/>
@@ -2736,6 +2765,7 @@
           <a:lstStyle xmlns:a="http://schemas.openxmlformats.org/drawingml/2006/main"/>
           <a:p xmlns:a="http://schemas.openxmlformats.org/drawingml/2006/main">
             <a:pPr algn="l">
+              <a:buNone/>
               <a:defRPr sz="975" b="1">
                 <a:solidFill>
                   <a:srgbClr val="D52B1E"/>
@@ -2794,6 +2824,7 @@
           <a:lstStyle xmlns:a="http://schemas.openxmlformats.org/drawingml/2006/main"/>
           <a:p xmlns:a="http://schemas.openxmlformats.org/drawingml/2006/main">
             <a:pPr algn="l">
+              <a:buNone/>
               <a:defRPr sz="1800" b="1">
                 <a:solidFill>
                   <a:srgbClr val="171717"/>
@@ -2852,6 +2883,7 @@
           <a:lstStyle xmlns:a="http://schemas.openxmlformats.org/drawingml/2006/main"/>
           <a:p xmlns:a="http://schemas.openxmlformats.org/drawingml/2006/main">
             <a:pPr algn="l">
+              <a:buNone/>
               <a:defRPr sz="1275" b="0">
                 <a:solidFill>
                   <a:srgbClr val="626262"/>
@@ -2945,6 +2977,7 @@
           <a:lstStyle xmlns:a="http://schemas.openxmlformats.org/drawingml/2006/main"/>
           <a:p xmlns:a="http://schemas.openxmlformats.org/drawingml/2006/main">
             <a:pPr algn="l">
+              <a:buNone/>
               <a:defRPr sz="975" b="1">
                 <a:solidFill>
                   <a:srgbClr val="D52B1E"/>
@@ -3003,6 +3036,7 @@
           <a:lstStyle xmlns:a="http://schemas.openxmlformats.org/drawingml/2006/main"/>
           <a:p xmlns:a="http://schemas.openxmlformats.org/drawingml/2006/main">
             <a:pPr algn="l">
+              <a:buNone/>
               <a:defRPr sz="1800" b="1">
                 <a:solidFill>
                   <a:srgbClr val="171717"/>
@@ -3061,6 +3095,7 @@
           <a:lstStyle xmlns:a="http://schemas.openxmlformats.org/drawingml/2006/main"/>
           <a:p xmlns:a="http://schemas.openxmlformats.org/drawingml/2006/main">
             <a:pPr algn="l">
+              <a:buNone/>
               <a:defRPr sz="1275" b="0">
                 <a:solidFill>
                   <a:srgbClr val="626262"/>
@@ -3154,6 +3189,7 @@
           <a:lstStyle xmlns:a="http://schemas.openxmlformats.org/drawingml/2006/main"/>
           <a:p xmlns:a="http://schemas.openxmlformats.org/drawingml/2006/main">
             <a:pPr algn="l">
+              <a:buNone/>
               <a:defRPr sz="975" b="1">
                 <a:solidFill>
                   <a:srgbClr val="D52B1E"/>
@@ -3212,6 +3248,7 @@
           <a:lstStyle xmlns:a="http://schemas.openxmlformats.org/drawingml/2006/main"/>
           <a:p xmlns:a="http://schemas.openxmlformats.org/drawingml/2006/main">
             <a:pPr algn="l">
+              <a:buNone/>
               <a:defRPr sz="1800" b="1">
                 <a:solidFill>
                   <a:srgbClr val="171717"/>
@@ -3270,6 +3307,7 @@
           <a:lstStyle xmlns:a="http://schemas.openxmlformats.org/drawingml/2006/main"/>
           <a:p xmlns:a="http://schemas.openxmlformats.org/drawingml/2006/main">
             <a:pPr algn="l">
+              <a:buNone/>
               <a:defRPr sz="1275" b="0">
                 <a:solidFill>
                   <a:srgbClr val="626262"/>
@@ -3357,6 +3395,7 @@
           <a:lstStyle xmlns:a="http://schemas.openxmlformats.org/drawingml/2006/main"/>
           <a:p xmlns:a="http://schemas.openxmlformats.org/drawingml/2006/main">
             <a:pPr algn="l">
+              <a:buNone/>
               <a:defRPr sz="1200" b="1">
                 <a:solidFill>
                   <a:srgbClr val="D52B1E"/>
@@ -3415,6 +3454,7 @@
           <a:lstStyle xmlns:a="http://schemas.openxmlformats.org/drawingml/2006/main"/>
           <a:p xmlns:a="http://schemas.openxmlformats.org/drawingml/2006/main">
             <a:pPr algn="l">
+              <a:buNone/>
               <a:defRPr sz="3300" b="1">
                 <a:solidFill>
                   <a:srgbClr val="171717"/>
@@ -3473,6 +3513,7 @@
           <a:lstStyle xmlns:a="http://schemas.openxmlformats.org/drawingml/2006/main"/>
           <a:p xmlns:a="http://schemas.openxmlformats.org/drawingml/2006/main">
             <a:pPr algn="l">
+              <a:buNone/>
               <a:defRPr sz="1500" b="0">
                 <a:solidFill>
                   <a:srgbClr val="626262"/>
@@ -3498,7 +3539,7 @@
       </p:sp>
       <p:cxnSp>
         <p:nvCxnSpPr>
-          <p:cNvPr id="50" name=""/>
+          <p:cNvPr id="142" name=""/>
           <p:cNvCxnSpPr/>
           <p:nvPr/>
         </p:nvCxnSpPr>
@@ -3553,6 +3594,7 @@
           <a:lstStyle xmlns:a="http://schemas.openxmlformats.org/drawingml/2006/main"/>
           <a:p xmlns:a="http://schemas.openxmlformats.org/drawingml/2006/main">
             <a:pPr algn="l">
+              <a:buNone/>
               <a:defRPr sz="900" b="1">
                 <a:solidFill>
                   <a:srgbClr val="D52B1E"/>
@@ -3611,6 +3653,7 @@
           <a:lstStyle xmlns:a="http://schemas.openxmlformats.org/drawingml/2006/main"/>
           <a:p xmlns:a="http://schemas.openxmlformats.org/drawingml/2006/main">
             <a:pPr algn="r">
+              <a:buNone/>
               <a:defRPr sz="900" b="0">
                 <a:solidFill>
                   <a:srgbClr val="626262"/>
@@ -3704,6 +3747,7 @@
           <a:lstStyle xmlns:a="http://schemas.openxmlformats.org/drawingml/2006/main"/>
           <a:p xmlns:a="http://schemas.openxmlformats.org/drawingml/2006/main">
             <a:pPr algn="l">
+              <a:buNone/>
               <a:defRPr sz="975" b="1">
                 <a:solidFill>
                   <a:srgbClr val="D52B1E"/>
@@ -3762,6 +3806,7 @@
           <a:lstStyle xmlns:a="http://schemas.openxmlformats.org/drawingml/2006/main"/>
           <a:p xmlns:a="http://schemas.openxmlformats.org/drawingml/2006/main">
             <a:pPr algn="l">
+              <a:buNone/>
               <a:defRPr sz="1575" b="1">
                 <a:solidFill>
                   <a:srgbClr val="171717"/>
@@ -3820,6 +3865,7 @@
           <a:lstStyle xmlns:a="http://schemas.openxmlformats.org/drawingml/2006/main"/>
           <a:p xmlns:a="http://schemas.openxmlformats.org/drawingml/2006/main">
             <a:pPr algn="l">
+              <a:buNone/>
               <a:defRPr sz="1125" b="0">
                 <a:solidFill>
                   <a:srgbClr val="626262"/>
@@ -3845,7 +3891,7 @@
       </p:sp>
       <p:cxnSp>
         <p:nvCxnSpPr>
-          <p:cNvPr id="57" name=""/>
+          <p:cNvPr id="149" name=""/>
           <p:cNvCxnSpPr/>
           <p:nvPr/>
         </p:nvCxnSpPr>
@@ -3935,6 +3981,7 @@
           <a:lstStyle xmlns:a="http://schemas.openxmlformats.org/drawingml/2006/main"/>
           <a:p xmlns:a="http://schemas.openxmlformats.org/drawingml/2006/main">
             <a:pPr algn="l">
+              <a:buNone/>
               <a:defRPr sz="975" b="1">
                 <a:solidFill>
                   <a:srgbClr val="D52B1E"/>
@@ -3993,6 +4040,7 @@
           <a:lstStyle xmlns:a="http://schemas.openxmlformats.org/drawingml/2006/main"/>
           <a:p xmlns:a="http://schemas.openxmlformats.org/drawingml/2006/main">
             <a:pPr algn="l">
+              <a:buNone/>
               <a:defRPr sz="1575" b="1">
                 <a:solidFill>
                   <a:srgbClr val="171717"/>
@@ -4051,6 +4099,7 @@
           <a:lstStyle xmlns:a="http://schemas.openxmlformats.org/drawingml/2006/main"/>
           <a:p xmlns:a="http://schemas.openxmlformats.org/drawingml/2006/main">
             <a:pPr algn="l">
+              <a:buNone/>
               <a:defRPr sz="1125" b="0">
                 <a:solidFill>
                   <a:srgbClr val="626262"/>
@@ -4076,7 +4125,7 @@
       </p:sp>
       <p:cxnSp>
         <p:nvCxnSpPr>
-          <p:cNvPr id="62" name=""/>
+          <p:cNvPr id="154" name=""/>
           <p:cNvCxnSpPr/>
           <p:nvPr/>
         </p:nvCxnSpPr>
@@ -4166,6 +4215,7 @@
           <a:lstStyle xmlns:a="http://schemas.openxmlformats.org/drawingml/2006/main"/>
           <a:p xmlns:a="http://schemas.openxmlformats.org/drawingml/2006/main">
             <a:pPr algn="l">
+              <a:buNone/>
               <a:defRPr sz="975" b="1">
                 <a:solidFill>
                   <a:srgbClr val="D52B1E"/>
@@ -4224,6 +4274,7 @@
           <a:lstStyle xmlns:a="http://schemas.openxmlformats.org/drawingml/2006/main"/>
           <a:p xmlns:a="http://schemas.openxmlformats.org/drawingml/2006/main">
             <a:pPr algn="l">
+              <a:buNone/>
               <a:defRPr sz="1575" b="1">
                 <a:solidFill>
                   <a:srgbClr val="171717"/>
@@ -4282,6 +4333,7 @@
           <a:lstStyle xmlns:a="http://schemas.openxmlformats.org/drawingml/2006/main"/>
           <a:p xmlns:a="http://schemas.openxmlformats.org/drawingml/2006/main">
             <a:pPr algn="l">
+              <a:buNone/>
               <a:defRPr sz="1125" b="0">
                 <a:solidFill>
                   <a:srgbClr val="626262"/>
@@ -4307,7 +4359,7 @@
       </p:sp>
       <p:cxnSp>
         <p:nvCxnSpPr>
-          <p:cNvPr id="67" name=""/>
+          <p:cNvPr id="159" name=""/>
           <p:cNvCxnSpPr/>
           <p:nvPr/>
         </p:nvCxnSpPr>
@@ -4397,6 +4449,7 @@
           <a:lstStyle xmlns:a="http://schemas.openxmlformats.org/drawingml/2006/main"/>
           <a:p xmlns:a="http://schemas.openxmlformats.org/drawingml/2006/main">
             <a:pPr algn="l">
+              <a:buNone/>
               <a:defRPr sz="975" b="1">
                 <a:solidFill>
                   <a:srgbClr val="D52B1E"/>
@@ -4455,6 +4508,7 @@
           <a:lstStyle xmlns:a="http://schemas.openxmlformats.org/drawingml/2006/main"/>
           <a:p xmlns:a="http://schemas.openxmlformats.org/drawingml/2006/main">
             <a:pPr algn="l">
+              <a:buNone/>
               <a:defRPr sz="1575" b="1">
                 <a:solidFill>
                   <a:srgbClr val="171717"/>
@@ -4513,6 +4567,7 @@
           <a:lstStyle xmlns:a="http://schemas.openxmlformats.org/drawingml/2006/main"/>
           <a:p xmlns:a="http://schemas.openxmlformats.org/drawingml/2006/main">
             <a:pPr algn="l">
+              <a:buNone/>
               <a:defRPr sz="1125" b="0">
                 <a:solidFill>
                   <a:srgbClr val="626262"/>
@@ -4606,6 +4661,7 @@
           <a:lstStyle xmlns:a="http://schemas.openxmlformats.org/drawingml/2006/main"/>
           <a:p xmlns:a="http://schemas.openxmlformats.org/drawingml/2006/main">
             <a:pPr algn="l">
+              <a:buNone/>
               <a:defRPr sz="975" b="1">
                 <a:solidFill>
                   <a:srgbClr val="D52B1E"/>
@@ -4664,6 +4720,7 @@
           <a:lstStyle xmlns:a="http://schemas.openxmlformats.org/drawingml/2006/main"/>
           <a:p xmlns:a="http://schemas.openxmlformats.org/drawingml/2006/main">
             <a:pPr algn="l">
+              <a:buNone/>
               <a:defRPr sz="1575" b="1">
                 <a:solidFill>
                   <a:srgbClr val="171717"/>
@@ -4722,6 +4779,7 @@
           <a:lstStyle xmlns:a="http://schemas.openxmlformats.org/drawingml/2006/main"/>
           <a:p xmlns:a="http://schemas.openxmlformats.org/drawingml/2006/main">
             <a:pPr algn="l">
+              <a:buNone/>
               <a:defRPr sz="1125" b="0">
                 <a:solidFill>
                   <a:srgbClr val="626262"/>
@@ -4747,7 +4805,7 @@
       </p:sp>
       <p:cxnSp>
         <p:nvCxnSpPr>
-          <p:cNvPr id="76" name=""/>
+          <p:cNvPr id="168" name=""/>
           <p:cNvCxnSpPr/>
           <p:nvPr/>
         </p:nvCxnSpPr>
@@ -4837,6 +4895,7 @@
           <a:lstStyle xmlns:a="http://schemas.openxmlformats.org/drawingml/2006/main"/>
           <a:p xmlns:a="http://schemas.openxmlformats.org/drawingml/2006/main">
             <a:pPr algn="l">
+              <a:buNone/>
               <a:defRPr sz="975" b="1">
                 <a:solidFill>
                   <a:srgbClr val="D52B1E"/>
@@ -4895,6 +4954,7 @@
           <a:lstStyle xmlns:a="http://schemas.openxmlformats.org/drawingml/2006/main"/>
           <a:p xmlns:a="http://schemas.openxmlformats.org/drawingml/2006/main">
             <a:pPr algn="l">
+              <a:buNone/>
               <a:defRPr sz="1575" b="1">
                 <a:solidFill>
                   <a:srgbClr val="171717"/>
@@ -4953,6 +5013,7 @@
           <a:lstStyle xmlns:a="http://schemas.openxmlformats.org/drawingml/2006/main"/>
           <a:p xmlns:a="http://schemas.openxmlformats.org/drawingml/2006/main">
             <a:pPr algn="l">
+              <a:buNone/>
               <a:defRPr sz="1125" b="0">
                 <a:solidFill>
                   <a:srgbClr val="626262"/>
@@ -4978,7 +5039,7 @@
       </p:sp>
       <p:cxnSp>
         <p:nvCxnSpPr>
-          <p:cNvPr id="81" name=""/>
+          <p:cNvPr id="173" name=""/>
           <p:cNvCxnSpPr/>
           <p:nvPr/>
         </p:nvCxnSpPr>
@@ -5068,6 +5129,7 @@
           <a:lstStyle xmlns:a="http://schemas.openxmlformats.org/drawingml/2006/main"/>
           <a:p xmlns:a="http://schemas.openxmlformats.org/drawingml/2006/main">
             <a:pPr algn="l">
+              <a:buNone/>
               <a:defRPr sz="975" b="1">
                 <a:solidFill>
                   <a:srgbClr val="D52B1E"/>
@@ -5126,6 +5188,7 @@
           <a:lstStyle xmlns:a="http://schemas.openxmlformats.org/drawingml/2006/main"/>
           <a:p xmlns:a="http://schemas.openxmlformats.org/drawingml/2006/main">
             <a:pPr algn="l">
+              <a:buNone/>
               <a:defRPr sz="1575" b="1">
                 <a:solidFill>
                   <a:srgbClr val="171717"/>
@@ -5184,6 +5247,7 @@
           <a:lstStyle xmlns:a="http://schemas.openxmlformats.org/drawingml/2006/main"/>
           <a:p xmlns:a="http://schemas.openxmlformats.org/drawingml/2006/main">
             <a:pPr algn="l">
+              <a:buNone/>
               <a:defRPr sz="1125" b="0">
                 <a:solidFill>
                   <a:srgbClr val="626262"/>
@@ -5202,14 +5266,14 @@
                 <a:ea typeface="Aptos"/>
                 <a:cs typeface="Aptos"/>
               </a:rPr>
-              <a:t>API, portal, doctor</a:t>
+              <a:t>Reports + extensions</a:t>
             </a:r>
           </a:p>
         </p:txBody>
       </p:sp>
       <p:cxnSp>
         <p:nvCxnSpPr>
-          <p:cNvPr id="86" name=""/>
+          <p:cNvPr id="178" name=""/>
           <p:cNvCxnSpPr/>
           <p:nvPr/>
         </p:nvCxnSpPr>
@@ -5299,6 +5363,7 @@
           <a:lstStyle xmlns:a="http://schemas.openxmlformats.org/drawingml/2006/main"/>
           <a:p xmlns:a="http://schemas.openxmlformats.org/drawingml/2006/main">
             <a:pPr algn="l">
+              <a:buNone/>
               <a:defRPr sz="975" b="1">
                 <a:solidFill>
                   <a:srgbClr val="D52B1E"/>
@@ -5357,6 +5422,7 @@
           <a:lstStyle xmlns:a="http://schemas.openxmlformats.org/drawingml/2006/main"/>
           <a:p xmlns:a="http://schemas.openxmlformats.org/drawingml/2006/main">
             <a:pPr algn="l">
+              <a:buNone/>
               <a:defRPr sz="1575" b="1">
                 <a:solidFill>
                   <a:srgbClr val="171717"/>
@@ -5415,6 +5481,7 @@
           <a:lstStyle xmlns:a="http://schemas.openxmlformats.org/drawingml/2006/main"/>
           <a:p xmlns:a="http://schemas.openxmlformats.org/drawingml/2006/main">
             <a:pPr algn="l">
+              <a:buNone/>
               <a:defRPr sz="1125" b="0">
                 <a:solidFill>
                   <a:srgbClr val="626262"/>
@@ -5440,7 +5507,7 @@
       </p:sp>
       <p:cxnSp>
         <p:nvCxnSpPr>
-          <p:cNvPr id="91" name=""/>
+          <p:cNvPr id="183" name=""/>
           <p:cNvCxnSpPr/>
           <p:nvPr/>
         </p:nvCxnSpPr>
@@ -5462,7 +5529,7 @@
       </p:cxnSp>
       <p:cxnSp>
         <p:nvCxnSpPr>
-          <p:cNvPr id="92" name=""/>
+          <p:cNvPr id="184" name=""/>
           <p:cNvCxnSpPr/>
           <p:nvPr/>
         </p:nvCxnSpPr>
@@ -5546,6 +5613,7 @@
           <a:lstStyle xmlns:a="http://schemas.openxmlformats.org/drawingml/2006/main"/>
           <a:p xmlns:a="http://schemas.openxmlformats.org/drawingml/2006/main">
             <a:pPr algn="l">
+              <a:buNone/>
               <a:defRPr sz="1200" b="1">
                 <a:solidFill>
                   <a:srgbClr val="D52B1E"/>
@@ -5604,6 +5672,7 @@
           <a:lstStyle xmlns:a="http://schemas.openxmlformats.org/drawingml/2006/main"/>
           <a:p xmlns:a="http://schemas.openxmlformats.org/drawingml/2006/main">
             <a:pPr algn="l">
+              <a:buNone/>
               <a:defRPr sz="3300" b="1">
                 <a:solidFill>
                   <a:srgbClr val="171717"/>
@@ -5662,6 +5731,7 @@
           <a:lstStyle xmlns:a="http://schemas.openxmlformats.org/drawingml/2006/main"/>
           <a:p xmlns:a="http://schemas.openxmlformats.org/drawingml/2006/main">
             <a:pPr algn="l">
+              <a:buNone/>
               <a:defRPr sz="1500" b="0">
                 <a:solidFill>
                   <a:srgbClr val="626262"/>
@@ -5687,7 +5757,7 @@
       </p:sp>
       <p:cxnSp>
         <p:nvCxnSpPr>
-          <p:cNvPr id="25" name=""/>
+          <p:cNvPr id="35" name=""/>
           <p:cNvCxnSpPr/>
           <p:nvPr/>
         </p:nvCxnSpPr>
@@ -5742,6 +5812,7 @@
           <a:lstStyle xmlns:a="http://schemas.openxmlformats.org/drawingml/2006/main"/>
           <a:p xmlns:a="http://schemas.openxmlformats.org/drawingml/2006/main">
             <a:pPr algn="l">
+              <a:buNone/>
               <a:defRPr sz="900" b="1">
                 <a:solidFill>
                   <a:srgbClr val="D52B1E"/>
@@ -5800,6 +5871,7 @@
           <a:lstStyle xmlns:a="http://schemas.openxmlformats.org/drawingml/2006/main"/>
           <a:p xmlns:a="http://schemas.openxmlformats.org/drawingml/2006/main">
             <a:pPr algn="r">
+              <a:buNone/>
               <a:defRPr sz="900" b="0">
                 <a:solidFill>
                   <a:srgbClr val="626262"/>
@@ -5825,14 +5897,14 @@
       </p:sp>
       <p:pic>
         <p:nvPicPr>
-          <p:cNvPr id="28" name=""/>
+          <p:cNvPr id="38" name=""/>
           <p:cNvPicPr>
             <a:picLocks xmlns:a="http://schemas.openxmlformats.org/drawingml/2006/main" noChangeAspect="1"/>
           </p:cNvPicPr>
           <p:nvPr/>
         </p:nvPicPr>
         <p:blipFill>
-          <a:blip xmlns:r="http://schemas.openxmlformats.org/officeDocument/2006/relationships" xmlns:a="http://schemas.openxmlformats.org/drawingml/2006/main" r:embed="R97a45d873be74823"/>
+          <a:blip xmlns:r="http://schemas.openxmlformats.org/officeDocument/2006/relationships" xmlns:a="http://schemas.openxmlformats.org/drawingml/2006/main" r:embed="Rb0bd3e60eb4f4d59"/>
           <a:stretch xmlns:a="http://schemas.openxmlformats.org/drawingml/2006/main"/>
         </p:blipFill>
         <p:spPr>
@@ -5917,6 +5989,7 @@
           <a:lstStyle xmlns:a="http://schemas.openxmlformats.org/drawingml/2006/main"/>
           <a:p xmlns:a="http://schemas.openxmlformats.org/drawingml/2006/main">
             <a:pPr algn="l">
+              <a:buNone/>
               <a:defRPr sz="1050" b="1">
                 <a:solidFill>
                   <a:srgbClr val="FFFFFF"/>
@@ -5975,6 +6048,7 @@
           <a:lstStyle xmlns:a="http://schemas.openxmlformats.org/drawingml/2006/main"/>
           <a:p xmlns:a="http://schemas.openxmlformats.org/drawingml/2006/main">
             <a:pPr algn="l">
+              <a:buNone/>
               <a:defRPr sz="900" b="1">
                 <a:solidFill>
                   <a:srgbClr val="D52B1E"/>
@@ -6033,6 +6107,7 @@
           <a:lstStyle xmlns:a="http://schemas.openxmlformats.org/drawingml/2006/main"/>
           <a:p xmlns:a="http://schemas.openxmlformats.org/drawingml/2006/main">
             <a:pPr algn="l">
+              <a:buNone/>
               <a:defRPr sz="1275" b="0">
                 <a:solidFill>
                   <a:srgbClr val="FFFFFF"/>
@@ -6091,6 +6166,7 @@
           <a:lstStyle xmlns:a="http://schemas.openxmlformats.org/drawingml/2006/main"/>
           <a:p xmlns:a="http://schemas.openxmlformats.org/drawingml/2006/main">
             <a:pPr algn="l">
+              <a:buNone/>
               <a:defRPr sz="900" b="1">
                 <a:solidFill>
                   <a:srgbClr val="D52B1E"/>
@@ -6149,6 +6225,7 @@
           <a:lstStyle xmlns:a="http://schemas.openxmlformats.org/drawingml/2006/main"/>
           <a:p xmlns:a="http://schemas.openxmlformats.org/drawingml/2006/main">
             <a:pPr algn="l">
+              <a:buNone/>
               <a:defRPr sz="1275" b="0">
                 <a:solidFill>
                   <a:srgbClr val="FFFFFF"/>
@@ -6207,6 +6284,7 @@
           <a:lstStyle xmlns:a="http://schemas.openxmlformats.org/drawingml/2006/main"/>
           <a:p xmlns:a="http://schemas.openxmlformats.org/drawingml/2006/main">
             <a:pPr algn="l">
+              <a:buNone/>
               <a:defRPr sz="900" b="1">
                 <a:solidFill>
                   <a:srgbClr val="D52B1E"/>
@@ -6265,6 +6343,7 @@
           <a:lstStyle xmlns:a="http://schemas.openxmlformats.org/drawingml/2006/main"/>
           <a:p xmlns:a="http://schemas.openxmlformats.org/drawingml/2006/main">
             <a:pPr algn="l">
+              <a:buNone/>
               <a:defRPr sz="1275" b="0">
                 <a:solidFill>
                   <a:srgbClr val="FFFFFF"/>
@@ -6323,6 +6402,7 @@
           <a:lstStyle xmlns:a="http://schemas.openxmlformats.org/drawingml/2006/main"/>
           <a:p xmlns:a="http://schemas.openxmlformats.org/drawingml/2006/main">
             <a:pPr algn="l">
+              <a:buNone/>
               <a:defRPr sz="900" b="1">
                 <a:solidFill>
                   <a:srgbClr val="D52B1E"/>
@@ -6381,6 +6461,7 @@
           <a:lstStyle xmlns:a="http://schemas.openxmlformats.org/drawingml/2006/main"/>
           <a:p xmlns:a="http://schemas.openxmlformats.org/drawingml/2006/main">
             <a:pPr algn="l">
+              <a:buNone/>
               <a:defRPr sz="1275" b="0">
                 <a:solidFill>
                   <a:srgbClr val="FFFFFF"/>
@@ -6439,6 +6520,7 @@
           <a:lstStyle xmlns:a="http://schemas.openxmlformats.org/drawingml/2006/main"/>
           <a:p xmlns:a="http://schemas.openxmlformats.org/drawingml/2006/main">
             <a:pPr algn="l">
+              <a:buNone/>
               <a:defRPr sz="900" b="1">
                 <a:solidFill>
                   <a:srgbClr val="D52B1E"/>
@@ -6497,6 +6579,7 @@
           <a:lstStyle xmlns:a="http://schemas.openxmlformats.org/drawingml/2006/main"/>
           <a:p xmlns:a="http://schemas.openxmlformats.org/drawingml/2006/main">
             <a:pPr algn="l">
+              <a:buNone/>
               <a:defRPr sz="1275" b="0">
                 <a:solidFill>
                   <a:srgbClr val="FFFFFF"/>
@@ -6555,6 +6638,7 @@
           <a:lstStyle xmlns:a="http://schemas.openxmlformats.org/drawingml/2006/main"/>
           <a:p xmlns:a="http://schemas.openxmlformats.org/drawingml/2006/main">
             <a:pPr algn="l">
+              <a:buNone/>
               <a:defRPr sz="900" b="1">
                 <a:solidFill>
                   <a:srgbClr val="D52B1E"/>
@@ -6613,6 +6697,7 @@
           <a:lstStyle xmlns:a="http://schemas.openxmlformats.org/drawingml/2006/main"/>
           <a:p xmlns:a="http://schemas.openxmlformats.org/drawingml/2006/main">
             <a:pPr algn="l">
+              <a:buNone/>
               <a:defRPr sz="1275" b="0">
                 <a:solidFill>
                   <a:srgbClr val="FFFFFF"/>
@@ -6700,6 +6785,7 @@
           <a:lstStyle xmlns:a="http://schemas.openxmlformats.org/drawingml/2006/main"/>
           <a:p xmlns:a="http://schemas.openxmlformats.org/drawingml/2006/main">
             <a:pPr algn="l">
+              <a:buNone/>
               <a:defRPr sz="1200" b="1">
                 <a:solidFill>
                   <a:srgbClr val="D52B1E"/>
@@ -6758,6 +6844,7 @@
           <a:lstStyle xmlns:a="http://schemas.openxmlformats.org/drawingml/2006/main"/>
           <a:p xmlns:a="http://schemas.openxmlformats.org/drawingml/2006/main">
             <a:pPr algn="l">
+              <a:buNone/>
               <a:defRPr sz="3300" b="1">
                 <a:solidFill>
                   <a:srgbClr val="171717"/>
@@ -6816,6 +6903,7 @@
           <a:lstStyle xmlns:a="http://schemas.openxmlformats.org/drawingml/2006/main"/>
           <a:p xmlns:a="http://schemas.openxmlformats.org/drawingml/2006/main">
             <a:pPr algn="l">
+              <a:buNone/>
               <a:defRPr sz="1500" b="0">
                 <a:solidFill>
                   <a:srgbClr val="626262"/>
@@ -6841,7 +6929,7 @@
       </p:sp>
       <p:cxnSp>
         <p:nvCxnSpPr>
-          <p:cNvPr id="26" name=""/>
+          <p:cNvPr id="40" name=""/>
           <p:cNvCxnSpPr/>
           <p:nvPr/>
         </p:nvCxnSpPr>
@@ -6896,6 +6984,7 @@
           <a:lstStyle xmlns:a="http://schemas.openxmlformats.org/drawingml/2006/main"/>
           <a:p xmlns:a="http://schemas.openxmlformats.org/drawingml/2006/main">
             <a:pPr algn="l">
+              <a:buNone/>
               <a:defRPr sz="900" b="1">
                 <a:solidFill>
                   <a:srgbClr val="D52B1E"/>
@@ -6954,6 +7043,7 @@
           <a:lstStyle xmlns:a="http://schemas.openxmlformats.org/drawingml/2006/main"/>
           <a:p xmlns:a="http://schemas.openxmlformats.org/drawingml/2006/main">
             <a:pPr algn="r">
+              <a:buNone/>
               <a:defRPr sz="900" b="0">
                 <a:solidFill>
                   <a:srgbClr val="626262"/>
@@ -6979,7 +7069,7 @@
       </p:sp>
       <p:cxnSp>
         <p:nvCxnSpPr>
-          <p:cNvPr id="29" name=""/>
+          <p:cNvPr id="43" name=""/>
           <p:cNvCxnSpPr/>
           <p:nvPr/>
         </p:nvCxnSpPr>
@@ -7069,6 +7159,7 @@
           <a:lstStyle xmlns:a="http://schemas.openxmlformats.org/drawingml/2006/main"/>
           <a:p xmlns:a="http://schemas.openxmlformats.org/drawingml/2006/main">
             <a:pPr algn="l">
+              <a:buNone/>
               <a:defRPr sz="1050" b="1">
                 <a:solidFill>
                   <a:srgbClr val="D52B1E"/>
@@ -7127,6 +7218,7 @@
           <a:lstStyle xmlns:a="http://schemas.openxmlformats.org/drawingml/2006/main"/>
           <a:p xmlns:a="http://schemas.openxmlformats.org/drawingml/2006/main">
             <a:pPr algn="l">
+              <a:buNone/>
               <a:defRPr sz="1875" b="1">
                 <a:solidFill>
                   <a:srgbClr val="171717"/>
@@ -7185,6 +7277,7 @@
           <a:lstStyle xmlns:a="http://schemas.openxmlformats.org/drawingml/2006/main"/>
           <a:p xmlns:a="http://schemas.openxmlformats.org/drawingml/2006/main">
             <a:pPr algn="l">
+              <a:buNone/>
               <a:defRPr sz="1350" b="0">
                 <a:solidFill>
                   <a:srgbClr val="626262"/>
@@ -7278,6 +7371,7 @@
           <a:lstStyle xmlns:a="http://schemas.openxmlformats.org/drawingml/2006/main"/>
           <a:p xmlns:a="http://schemas.openxmlformats.org/drawingml/2006/main">
             <a:pPr algn="l">
+              <a:buNone/>
               <a:defRPr sz="1050" b="1">
                 <a:solidFill>
                   <a:srgbClr val="D52B1E"/>
@@ -7336,6 +7430,7 @@
           <a:lstStyle xmlns:a="http://schemas.openxmlformats.org/drawingml/2006/main"/>
           <a:p xmlns:a="http://schemas.openxmlformats.org/drawingml/2006/main">
             <a:pPr algn="l">
+              <a:buNone/>
               <a:defRPr sz="1875" b="1">
                 <a:solidFill>
                   <a:srgbClr val="171717"/>
@@ -7394,6 +7489,7 @@
           <a:lstStyle xmlns:a="http://schemas.openxmlformats.org/drawingml/2006/main"/>
           <a:p xmlns:a="http://schemas.openxmlformats.org/drawingml/2006/main">
             <a:pPr algn="l">
+              <a:buNone/>
               <a:defRPr sz="1350" b="0">
                 <a:solidFill>
                   <a:srgbClr val="626262"/>
@@ -7487,6 +7583,7 @@
           <a:lstStyle xmlns:a="http://schemas.openxmlformats.org/drawingml/2006/main"/>
           <a:p xmlns:a="http://schemas.openxmlformats.org/drawingml/2006/main">
             <a:pPr algn="l">
+              <a:buNone/>
               <a:defRPr sz="1050" b="1">
                 <a:solidFill>
                   <a:srgbClr val="D52B1E"/>
@@ -7545,6 +7642,7 @@
           <a:lstStyle xmlns:a="http://schemas.openxmlformats.org/drawingml/2006/main"/>
           <a:p xmlns:a="http://schemas.openxmlformats.org/drawingml/2006/main">
             <a:pPr algn="l">
+              <a:buNone/>
               <a:defRPr sz="1875" b="1">
                 <a:solidFill>
                   <a:srgbClr val="171717"/>
@@ -7603,6 +7701,7 @@
           <a:lstStyle xmlns:a="http://schemas.openxmlformats.org/drawingml/2006/main"/>
           <a:p xmlns:a="http://schemas.openxmlformats.org/drawingml/2006/main">
             <a:pPr algn="l">
+              <a:buNone/>
               <a:defRPr sz="1350" b="0">
                 <a:solidFill>
                   <a:srgbClr val="626262"/>
@@ -7694,6 +7793,7 @@
           <a:lstStyle xmlns:a="http://schemas.openxmlformats.org/drawingml/2006/main"/>
           <a:p xmlns:a="http://schemas.openxmlformats.org/drawingml/2006/main">
             <a:pPr algn="l">
+              <a:buNone/>
               <a:defRPr sz="1125" b="1">
                 <a:solidFill>
                   <a:srgbClr val="D52B1E"/>
@@ -7752,6 +7852,7 @@
           <a:lstStyle xmlns:a="http://schemas.openxmlformats.org/drawingml/2006/main"/>
           <a:p xmlns:a="http://schemas.openxmlformats.org/drawingml/2006/main">
             <a:pPr algn="r">
+              <a:buNone/>
               <a:defRPr sz="1125" b="1">
                 <a:solidFill>
                   <a:srgbClr val="171717"/>
@@ -7839,6 +7940,7 @@
           <a:lstStyle xmlns:a="http://schemas.openxmlformats.org/drawingml/2006/main"/>
           <a:p xmlns:a="http://schemas.openxmlformats.org/drawingml/2006/main">
             <a:pPr algn="l">
+              <a:buNone/>
               <a:defRPr sz="1200" b="1">
                 <a:solidFill>
                   <a:srgbClr val="D52B1E"/>
@@ -7897,6 +7999,7 @@
           <a:lstStyle xmlns:a="http://schemas.openxmlformats.org/drawingml/2006/main"/>
           <a:p xmlns:a="http://schemas.openxmlformats.org/drawingml/2006/main">
             <a:pPr algn="l">
+              <a:buNone/>
               <a:defRPr sz="3300" b="1">
                 <a:solidFill>
                   <a:srgbClr val="171717"/>
@@ -7955,6 +8058,7 @@
           <a:lstStyle xmlns:a="http://schemas.openxmlformats.org/drawingml/2006/main"/>
           <a:p xmlns:a="http://schemas.openxmlformats.org/drawingml/2006/main">
             <a:pPr algn="l">
+              <a:buNone/>
               <a:defRPr sz="1500" b="0">
                 <a:solidFill>
                   <a:srgbClr val="626262"/>
@@ -7980,7 +8084,7 @@
       </p:sp>
       <p:cxnSp>
         <p:nvCxnSpPr>
-          <p:cNvPr id="26" name=""/>
+          <p:cNvPr id="34" name=""/>
           <p:cNvCxnSpPr/>
           <p:nvPr/>
         </p:nvCxnSpPr>
@@ -8035,6 +8139,7 @@
           <a:lstStyle xmlns:a="http://schemas.openxmlformats.org/drawingml/2006/main"/>
           <a:p xmlns:a="http://schemas.openxmlformats.org/drawingml/2006/main">
             <a:pPr algn="l">
+              <a:buNone/>
               <a:defRPr sz="900" b="1">
                 <a:solidFill>
                   <a:srgbClr val="D52B1E"/>
@@ -8093,6 +8198,7 @@
           <a:lstStyle xmlns:a="http://schemas.openxmlformats.org/drawingml/2006/main"/>
           <a:p xmlns:a="http://schemas.openxmlformats.org/drawingml/2006/main">
             <a:pPr algn="r">
+              <a:buNone/>
               <a:defRPr sz="900" b="0">
                 <a:solidFill>
                   <a:srgbClr val="626262"/>
@@ -8186,6 +8292,7 @@
           <a:lstStyle xmlns:a="http://schemas.openxmlformats.org/drawingml/2006/main"/>
           <a:p xmlns:a="http://schemas.openxmlformats.org/drawingml/2006/main">
             <a:pPr algn="l">
+              <a:buNone/>
               <a:defRPr sz="975" b="1">
                 <a:solidFill>
                   <a:srgbClr val="D52B1E"/>
@@ -8244,6 +8351,7 @@
           <a:lstStyle xmlns:a="http://schemas.openxmlformats.org/drawingml/2006/main"/>
           <a:p xmlns:a="http://schemas.openxmlformats.org/drawingml/2006/main">
             <a:pPr algn="l">
+              <a:buNone/>
               <a:defRPr sz="1800" b="1">
                 <a:solidFill>
                   <a:srgbClr val="171717"/>
@@ -8302,6 +8410,7 @@
           <a:lstStyle xmlns:a="http://schemas.openxmlformats.org/drawingml/2006/main"/>
           <a:p xmlns:a="http://schemas.openxmlformats.org/drawingml/2006/main">
             <a:pPr algn="l">
+              <a:buNone/>
               <a:defRPr sz="1275" b="0">
                 <a:solidFill>
                   <a:srgbClr val="626262"/>
@@ -8395,6 +8504,7 @@
           <a:lstStyle xmlns:a="http://schemas.openxmlformats.org/drawingml/2006/main"/>
           <a:p xmlns:a="http://schemas.openxmlformats.org/drawingml/2006/main">
             <a:pPr algn="l">
+              <a:buNone/>
               <a:defRPr sz="975" b="1">
                 <a:solidFill>
                   <a:srgbClr val="D52B1E"/>
@@ -8453,6 +8563,7 @@
           <a:lstStyle xmlns:a="http://schemas.openxmlformats.org/drawingml/2006/main"/>
           <a:p xmlns:a="http://schemas.openxmlformats.org/drawingml/2006/main">
             <a:pPr algn="l">
+              <a:buNone/>
               <a:defRPr sz="1800" b="1">
                 <a:solidFill>
                   <a:srgbClr val="171717"/>
@@ -8511,6 +8622,7 @@
           <a:lstStyle xmlns:a="http://schemas.openxmlformats.org/drawingml/2006/main"/>
           <a:p xmlns:a="http://schemas.openxmlformats.org/drawingml/2006/main">
             <a:pPr algn="l">
+              <a:buNone/>
               <a:defRPr sz="1275" b="0">
                 <a:solidFill>
                   <a:srgbClr val="626262"/>
@@ -8604,6 +8716,7 @@
           <a:lstStyle xmlns:a="http://schemas.openxmlformats.org/drawingml/2006/main"/>
           <a:p xmlns:a="http://schemas.openxmlformats.org/drawingml/2006/main">
             <a:pPr algn="l">
+              <a:buNone/>
               <a:defRPr sz="975" b="1">
                 <a:solidFill>
                   <a:srgbClr val="D52B1E"/>
@@ -8662,6 +8775,7 @@
           <a:lstStyle xmlns:a="http://schemas.openxmlformats.org/drawingml/2006/main"/>
           <a:p xmlns:a="http://schemas.openxmlformats.org/drawingml/2006/main">
             <a:pPr algn="l">
+              <a:buNone/>
               <a:defRPr sz="1800" b="1">
                 <a:solidFill>
                   <a:srgbClr val="171717"/>
@@ -8720,6 +8834,7 @@
           <a:lstStyle xmlns:a="http://schemas.openxmlformats.org/drawingml/2006/main"/>
           <a:p xmlns:a="http://schemas.openxmlformats.org/drawingml/2006/main">
             <a:pPr algn="l">
+              <a:buNone/>
               <a:defRPr sz="1275" b="0">
                 <a:solidFill>
                   <a:srgbClr val="626262"/>
@@ -8813,6 +8928,7 @@
           <a:lstStyle xmlns:a="http://schemas.openxmlformats.org/drawingml/2006/main"/>
           <a:p xmlns:a="http://schemas.openxmlformats.org/drawingml/2006/main">
             <a:pPr algn="l">
+              <a:buNone/>
               <a:defRPr sz="975" b="1">
                 <a:solidFill>
                   <a:srgbClr val="D52B1E"/>
@@ -8871,6 +8987,7 @@
           <a:lstStyle xmlns:a="http://schemas.openxmlformats.org/drawingml/2006/main"/>
           <a:p xmlns:a="http://schemas.openxmlformats.org/drawingml/2006/main">
             <a:pPr algn="l">
+              <a:buNone/>
               <a:defRPr sz="1800" b="1">
                 <a:solidFill>
                   <a:srgbClr val="171717"/>
@@ -8929,6 +9046,7 @@
           <a:lstStyle xmlns:a="http://schemas.openxmlformats.org/drawingml/2006/main"/>
           <a:p xmlns:a="http://schemas.openxmlformats.org/drawingml/2006/main">
             <a:pPr algn="l">
+              <a:buNone/>
               <a:defRPr sz="1275" b="0">
                 <a:solidFill>
                   <a:srgbClr val="626262"/>
@@ -9016,6 +9134,7 @@
           <a:lstStyle xmlns:a="http://schemas.openxmlformats.org/drawingml/2006/main"/>
           <a:p xmlns:a="http://schemas.openxmlformats.org/drawingml/2006/main">
             <a:pPr algn="l">
+              <a:buNone/>
               <a:defRPr sz="1200" b="1">
                 <a:solidFill>
                   <a:srgbClr val="D52B1E"/>
@@ -9074,6 +9193,7 @@
           <a:lstStyle xmlns:a="http://schemas.openxmlformats.org/drawingml/2006/main"/>
           <a:p xmlns:a="http://schemas.openxmlformats.org/drawingml/2006/main">
             <a:pPr algn="l">
+              <a:buNone/>
               <a:defRPr sz="3300" b="1">
                 <a:solidFill>
                   <a:srgbClr val="171717"/>
@@ -9132,6 +9252,7 @@
           <a:lstStyle xmlns:a="http://schemas.openxmlformats.org/drawingml/2006/main"/>
           <a:p xmlns:a="http://schemas.openxmlformats.org/drawingml/2006/main">
             <a:pPr algn="l">
+              <a:buNone/>
               <a:defRPr sz="1500" b="0">
                 <a:solidFill>
                   <a:srgbClr val="626262"/>
@@ -9157,7 +9278,7 @@
       </p:sp>
       <p:cxnSp>
         <p:nvCxnSpPr>
-          <p:cNvPr id="23" name=""/>
+          <p:cNvPr id="31" name=""/>
           <p:cNvCxnSpPr/>
           <p:nvPr/>
         </p:nvCxnSpPr>
@@ -9212,6 +9333,7 @@
           <a:lstStyle xmlns:a="http://schemas.openxmlformats.org/drawingml/2006/main"/>
           <a:p xmlns:a="http://schemas.openxmlformats.org/drawingml/2006/main">
             <a:pPr algn="l">
+              <a:buNone/>
               <a:defRPr sz="900" b="1">
                 <a:solidFill>
                   <a:srgbClr val="D52B1E"/>
@@ -9270,6 +9392,7 @@
           <a:lstStyle xmlns:a="http://schemas.openxmlformats.org/drawingml/2006/main"/>
           <a:p xmlns:a="http://schemas.openxmlformats.org/drawingml/2006/main">
             <a:pPr algn="r">
+              <a:buNone/>
               <a:defRPr sz="900" b="0">
                 <a:solidFill>
                   <a:srgbClr val="626262"/>
@@ -9328,6 +9451,7 @@
           <a:lstStyle xmlns:a="http://schemas.openxmlformats.org/drawingml/2006/main"/>
           <a:p xmlns:a="http://schemas.openxmlformats.org/drawingml/2006/main">
             <a:pPr algn="l">
+              <a:buNone/>
               <a:defRPr sz="1575" b="0">
                 <a:solidFill>
                   <a:srgbClr val="626262"/>
@@ -9421,6 +9545,7 @@
           <a:lstStyle xmlns:a="http://schemas.openxmlformats.org/drawingml/2006/main"/>
           <a:p xmlns:a="http://schemas.openxmlformats.org/drawingml/2006/main">
             <a:pPr algn="l">
+              <a:buNone/>
               <a:defRPr sz="5400" b="1">
                 <a:solidFill>
                   <a:srgbClr val="D52B1E"/>
@@ -9439,7 +9564,7 @@
                 <a:ea typeface="Aptos"/>
                 <a:cs typeface="Aptos"/>
               </a:rPr>
-              <a:t>~75% → 100%</a:t>
+              <a:t>4</a:t>
             </a:r>
           </a:p>
         </p:txBody>
@@ -9479,6 +9604,7 @@
           <a:lstStyle xmlns:a="http://schemas.openxmlformats.org/drawingml/2006/main"/>
           <a:p xmlns:a="http://schemas.openxmlformats.org/drawingml/2006/main">
             <a:pPr algn="l">
+              <a:buNone/>
               <a:defRPr sz="1500" b="1">
                 <a:solidFill>
                   <a:srgbClr val="171717"/>
@@ -9497,7 +9623,7 @@
                 <a:ea typeface="Aptos"/>
                 <a:cs typeface="Aptos"/>
               </a:rPr>
-              <a:t>reviewed conformance</a:t>
+              <a:t>report families</a:t>
             </a:r>
           </a:p>
         </p:txBody>
@@ -9537,6 +9663,7 @@
           <a:lstStyle xmlns:a="http://schemas.openxmlformats.org/drawingml/2006/main"/>
           <a:p xmlns:a="http://schemas.openxmlformats.org/drawingml/2006/main">
             <a:pPr algn="l">
+              <a:buNone/>
               <a:defRPr sz="1200" b="0">
                 <a:solidFill>
                   <a:srgbClr val="626262"/>
@@ -9555,7 +9682,7 @@
                 <a:ea typeface="Aptos"/>
                 <a:cs typeface="Aptos"/>
               </a:rPr>
-              <a:t>Production-count schema · approx. six months</a:t>
+              <a:t>Shift drafts · daily · weekly · downtime</a:t>
             </a:r>
           </a:p>
         </p:txBody>
@@ -9630,6 +9757,7 @@
           <a:lstStyle xmlns:a="http://schemas.openxmlformats.org/drawingml/2006/main"/>
           <a:p xmlns:a="http://schemas.openxmlformats.org/drawingml/2006/main">
             <a:pPr algn="l">
+              <a:buNone/>
               <a:defRPr sz="5400" b="1">
                 <a:solidFill>
                   <a:srgbClr val="D52B1E"/>
@@ -9688,6 +9816,7 @@
           <a:lstStyle xmlns:a="http://schemas.openxmlformats.org/drawingml/2006/main"/>
           <a:p xmlns:a="http://schemas.openxmlformats.org/drawingml/2006/main">
             <a:pPr algn="l">
+              <a:buNone/>
               <a:defRPr sz="1500" b="1">
                 <a:solidFill>
                   <a:srgbClr val="171717"/>
@@ -9746,6 +9875,7 @@
           <a:lstStyle xmlns:a="http://schemas.openxmlformats.org/drawingml/2006/main"/>
           <a:p xmlns:a="http://schemas.openxmlformats.org/drawingml/2006/main">
             <a:pPr algn="l">
+              <a:buNone/>
               <a:defRPr sz="1200" b="0">
                 <a:solidFill>
                   <a:srgbClr val="626262"/>
@@ -9839,6 +9969,7 @@
           <a:lstStyle xmlns:a="http://schemas.openxmlformats.org/drawingml/2006/main"/>
           <a:p xmlns:a="http://schemas.openxmlformats.org/drawingml/2006/main">
             <a:pPr algn="l">
+              <a:buNone/>
               <a:defRPr sz="5400" b="1">
                 <a:solidFill>
                   <a:srgbClr val="D52B1E"/>
@@ -9897,6 +10028,7 @@
           <a:lstStyle xmlns:a="http://schemas.openxmlformats.org/drawingml/2006/main"/>
           <a:p xmlns:a="http://schemas.openxmlformats.org/drawingml/2006/main">
             <a:pPr algn="l">
+              <a:buNone/>
               <a:defRPr sz="1500" b="1">
                 <a:solidFill>
                   <a:srgbClr val="171717"/>
@@ -9955,6 +10087,7 @@
           <a:lstStyle xmlns:a="http://schemas.openxmlformats.org/drawingml/2006/main"/>
           <a:p xmlns:a="http://schemas.openxmlformats.org/drawingml/2006/main">
             <a:pPr algn="l">
+              <a:buNone/>
               <a:defRPr sz="1200" b="0">
                 <a:solidFill>
                   <a:srgbClr val="626262"/>
@@ -10042,6 +10175,7 @@
           <a:lstStyle xmlns:a="http://schemas.openxmlformats.org/drawingml/2006/main"/>
           <a:p xmlns:a="http://schemas.openxmlformats.org/drawingml/2006/main">
             <a:pPr algn="l">
+              <a:buNone/>
               <a:defRPr sz="1200" b="1">
                 <a:solidFill>
                   <a:srgbClr val="D52B1E"/>
@@ -10100,6 +10234,7 @@
           <a:lstStyle xmlns:a="http://schemas.openxmlformats.org/drawingml/2006/main"/>
           <a:p xmlns:a="http://schemas.openxmlformats.org/drawingml/2006/main">
             <a:pPr algn="l">
+              <a:buNone/>
               <a:defRPr sz="4950" b="1">
                 <a:solidFill>
                   <a:srgbClr val="171717"/>
@@ -10158,6 +10293,7 @@
           <a:lstStyle xmlns:a="http://schemas.openxmlformats.org/drawingml/2006/main"/>
           <a:p xmlns:a="http://schemas.openxmlformats.org/drawingml/2006/main">
             <a:pPr algn="l">
+              <a:buNone/>
               <a:defRPr sz="1875" b="0">
                 <a:solidFill>
                   <a:srgbClr val="626262"/>
@@ -10181,6 +10317,7 @@
           </a:p>
           <a:p xmlns:a="http://schemas.openxmlformats.org/drawingml/2006/main">
             <a:pPr algn="l">
+              <a:buNone/>
               <a:defRPr sz="1875" b="0">
                 <a:solidFill>
                   <a:srgbClr val="626262"/>
@@ -10204,6 +10341,7 @@
           </a:p>
           <a:p xmlns:a="http://schemas.openxmlformats.org/drawingml/2006/main">
             <a:pPr algn="l">
+              <a:buNone/>
               <a:defRPr sz="1875" b="0">
                 <a:solidFill>
                   <a:srgbClr val="626262"/>
@@ -10227,6 +10365,7 @@
           </a:p>
           <a:p xmlns:a="http://schemas.openxmlformats.org/drawingml/2006/main">
             <a:pPr algn="l">
+              <a:buNone/>
               <a:defRPr sz="1875" b="0">
                 <a:solidFill>
                   <a:srgbClr val="626262"/>
@@ -10250,6 +10389,7 @@
           </a:p>
           <a:p xmlns:a="http://schemas.openxmlformats.org/drawingml/2006/main">
             <a:pPr algn="l">
+              <a:buNone/>
               <a:defRPr sz="1875" b="0">
                 <a:solidFill>
                   <a:srgbClr val="626262"/>
@@ -10268,7 +10408,7 @@
                 <a:ea typeface="Aptos"/>
                 <a:cs typeface="Aptos"/>
               </a:rPr>
-              <a:t>Turn incidents into synthetic regressions.</a:t>
+              <a:t>Keep the assistant read-only; gate broader AI.</a:t>
             </a:r>
           </a:p>
         </p:txBody>
@@ -10343,6 +10483,7 @@
           <a:lstStyle xmlns:a="http://schemas.openxmlformats.org/drawingml/2006/main"/>
           <a:p xmlns:a="http://schemas.openxmlformats.org/drawingml/2006/main">
             <a:pPr algn="l">
+              <a:buNone/>
               <a:defRPr sz="1350" b="1">
                 <a:solidFill>
                   <a:srgbClr val="FFFFFF"/>
@@ -10401,6 +10542,7 @@
           <a:lstStyle xmlns:a="http://schemas.openxmlformats.org/drawingml/2006/main"/>
           <a:p xmlns:a="http://schemas.openxmlformats.org/drawingml/2006/main">
             <a:pPr algn="l">
+              <a:buNone/>
               <a:defRPr sz="1500" b="0">
                 <a:solidFill>
                   <a:srgbClr val="FFFFFF"/>
@@ -10424,6 +10566,7 @@
           </a:p>
           <a:p xmlns:a="http://schemas.openxmlformats.org/drawingml/2006/main">
             <a:pPr algn="l">
+              <a:buNone/>
               <a:defRPr sz="1500" b="0">
                 <a:solidFill>
                   <a:srgbClr val="FFFFFF"/>
@@ -10482,6 +10625,7 @@
           <a:lstStyle xmlns:a="http://schemas.openxmlformats.org/drawingml/2006/main"/>
           <a:p xmlns:a="http://schemas.openxmlformats.org/drawingml/2006/main">
             <a:pPr algn="l">
+              <a:buNone/>
               <a:defRPr sz="1125" b="0">
                 <a:solidFill>
                   <a:srgbClr val="FFFFFF"/>
@@ -10505,6 +10649,7 @@
           </a:p>
           <a:p xmlns:a="http://schemas.openxmlformats.org/drawingml/2006/main">
             <a:pPr algn="l">
+              <a:buNone/>
               <a:defRPr sz="1125" b="0">
                 <a:solidFill>
                   <a:srgbClr val="FFFFFF"/>
@@ -10528,6 +10673,7 @@
           </a:p>
           <a:p xmlns:a="http://schemas.openxmlformats.org/drawingml/2006/main">
             <a:pPr algn="l">
+              <a:buNone/>
               <a:defRPr sz="1125" b="0">
                 <a:solidFill>
                   <a:srgbClr val="FFFFFF"/>
@@ -10553,7 +10699,7 @@
       </p:sp>
       <p:cxnSp>
         <p:nvCxnSpPr>
-          <p:cNvPr id="18" name=""/>
+          <p:cNvPr id="34" name=""/>
           <p:cNvCxnSpPr/>
           <p:nvPr/>
         </p:nvCxnSpPr>
@@ -10608,6 +10754,7 @@
           <a:lstStyle xmlns:a="http://schemas.openxmlformats.org/drawingml/2006/main"/>
           <a:p xmlns:a="http://schemas.openxmlformats.org/drawingml/2006/main">
             <a:pPr algn="l">
+              <a:buNone/>
               <a:defRPr sz="900" b="1">
                 <a:solidFill>
                   <a:srgbClr val="D52B1E"/>
@@ -10666,6 +10813,7 @@
           <a:lstStyle xmlns:a="http://schemas.openxmlformats.org/drawingml/2006/main"/>
           <a:p xmlns:a="http://schemas.openxmlformats.org/drawingml/2006/main">
             <a:pPr algn="r">
+              <a:buNone/>
               <a:defRPr sz="900" b="0">
                 <a:solidFill>
                   <a:srgbClr val="626262"/>

</xml_diff>